<commit_message>
Center VEPRAD in presentation narrative
</commit_message>
<xml_diff>
--- a/presentation/ROGJ_Deepspeech2_topic_presentation.pptx
+++ b/presentation/ROGJ_Deepspeech2_topic_presentation.pptx
@@ -390,7 +390,7 @@
                 </a:solidFill>
                 <a:latin typeface="Aptos"/>
               </a:rPr>
-              <a:t>VEPRAD -&gt; splitovi -&gt; DeepSpeech2 trening -&gt; KenLM dekodiranje -&gt; WER/CER</a:t>
+              <a:t>VEPRAD -&gt; DeepSpeech2 trening -&gt; KenLM -&gt; WER/CER</a:t>
             </a:r>
             <a:endParaRPr lang="hr-HR" sz="2100"/>
           </a:p>
@@ -708,7 +708,7 @@
                 </a:solidFill>
                 <a:latin typeface="Aptos"/>
               </a:rPr>
-              <a:t>U prezentaciji: kako smo izolirali test skup, kako je definiran CV split, koje DS2 konfiguracije smo trenirali i koliko KenLM mijenja rezultate.</a:t>
+              <a:t>U prezentaciji: kako smo pripremili VEPRAD, izolirali test skup, definirali CV splitove, trenirali DS2 konfiguracije i izmjerili utjecaj KenLM-a.</a:t>
             </a:r>
             <a:endParaRPr lang="hr-HR" sz="1900"/>
           </a:p>
@@ -813,7 +813,7 @@
                 </a:solidFill>
                 <a:latin typeface="Aptos"/>
               </a:rPr>
-              <a:t>02 · PODACI I SPLITOVI</a:t>
+              <a:t>02 · VEPRAD PODACI I SPLITOVI</a:t>
             </a:r>
             <a:endParaRPr lang="hr-HR" sz="1500"/>
           </a:p>
@@ -828,30 +828,30 @@
         <p:spPr>
           <a:xfrm>
             <a:off x="444500" y="520700"/>
-            <a:ext cx="7493000" cy="393700"/>
-          </a:xfrm>
-          <a:prstGeom prst="rect">
-            <a:avLst/>
-          </a:prstGeom>
-          <a:noFill/>
-          <a:ln>
-            <a:noFill/>
-          </a:ln>
-        </p:spPr>
-        <p:txBody>
-          <a:bodyPr wrap="square" lIns="0" tIns="0" rIns="0" bIns="0"/>
-          <a:lstStyle/>
-          <a:p>
-            <a:r>
-              <a:rPr lang="hr-HR" sz="2500" b="1">
+            <a:ext cx="7937500" cy="546100"/>
+          </a:xfrm>
+          <a:prstGeom prst="rect">
+            <a:avLst/>
+          </a:prstGeom>
+          <a:noFill/>
+          <a:ln>
+            <a:noFill/>
+          </a:ln>
+        </p:spPr>
+        <p:txBody>
+          <a:bodyPr wrap="square" lIns="0" tIns="0" rIns="0" bIns="0"/>
+          <a:lstStyle/>
+          <a:p>
+            <a:r>
+              <a:rPr lang="hr-HR" sz="2350" b="1">
                 <a:solidFill>
                   <a:srgbClr val="15171A"/>
                 </a:solidFill>
                 <a:latin typeface="Aptos"/>
               </a:rPr>
-              <a:t>Test skup je odvojen prije cross-validacije.</a:t>
-            </a:r>
-            <a:endParaRPr lang="hr-HR" sz="2500"/>
+              <a:t>VEPRAD test skup je odvojen prije cross-validacije.</a:t>
+            </a:r>
+            <a:endParaRPr lang="hr-HR" sz="2350"/>
           </a:p>
         </p:txBody>
       </p:sp>
@@ -863,31 +863,31 @@
         </p:nvSpPr>
         <p:spPr>
           <a:xfrm>
-            <a:off x="444500" y="952500"/>
-            <a:ext cx="7493000" cy="292100"/>
-          </a:xfrm>
-          <a:prstGeom prst="rect">
-            <a:avLst/>
-          </a:prstGeom>
-          <a:noFill/>
-          <a:ln>
-            <a:noFill/>
-          </a:ln>
-        </p:spPr>
-        <p:txBody>
-          <a:bodyPr wrap="square" lIns="0" tIns="0" rIns="0" bIns="0"/>
-          <a:lstStyle/>
-          <a:p>
-            <a:r>
-              <a:rPr lang="hr-HR" sz="1180">
+            <a:off x="444500" y="1130300"/>
+            <a:ext cx="7937500" cy="266700"/>
+          </a:xfrm>
+          <a:prstGeom prst="rect">
+            <a:avLst/>
+          </a:prstGeom>
+          <a:noFill/>
+          <a:ln>
+            <a:noFill/>
+          </a:ln>
+        </p:spPr>
+        <p:txBody>
+          <a:bodyPr wrap="square" lIns="0" tIns="0" rIns="0" bIns="0"/>
+          <a:lstStyle/>
+          <a:p>
+            <a:r>
+              <a:rPr lang="hr-HR" sz="1080">
                 <a:solidFill>
                   <a:srgbClr val="6F6A5B"/>
                 </a:solidFill>
                 <a:latin typeface="Aptos"/>
               </a:rPr>
-              <a:t>VEPRAD se tretira kao govor + transkript, s govornicima kao važnom osi generalizacije.</a:t>
-            </a:r>
-            <a:endParaRPr lang="hr-HR" sz="1180"/>
+              <a:t>Skup koristimo kao uparene audio snimke i transkripte, a govornike držimo kao posebnu os generalizacije.</a:t>
+            </a:r>
+            <a:endParaRPr lang="hr-HR" sz="1080"/>
           </a:p>
         </p:txBody>
       </p:sp>
@@ -899,7 +899,7 @@
         </p:nvSpPr>
         <p:spPr>
           <a:xfrm>
-            <a:off x="444500" y="1333500"/>
+            <a:off x="444500" y="1447800"/>
             <a:ext cx="736600" cy="44450"/>
           </a:xfrm>
           <a:prstGeom prst="rect">
@@ -943,7 +943,7 @@
                 </a:solidFill>
                 <a:latin typeface="Aptos"/>
               </a:rPr>
-              <a:t>Permanentni test skup</a:t>
+              <a:t>Permanentni test</a:t>
             </a:r>
             <a:endParaRPr lang="hr-HR" sz="1800"/>
           </a:p>
@@ -1247,7 +1247,7 @@
                 </a:solidFill>
                 <a:latin typeface="Aptos"/>
               </a:rPr>
-              <a:t>test audio + test JSONL žive u data/test i ne ulaze u CV</a:t>
+              <a:t>VEPRAD test audio + JSONL žive u data/test i ne ulaze u CV</a:t>
             </a:r>
             <a:endParaRPr lang="hr-HR" sz="1250"/>
           </a:p>
@@ -1319,7 +1319,7 @@
                 </a:solidFill>
                 <a:latin typeface="Aptos"/>
               </a:rPr>
-              <a:t>Jedan CV split</a:t>
+              <a:t>Jedan VEPRAD CV split</a:t>
             </a:r>
             <a:endParaRPr lang="hr-HR" sz="1800"/>
           </a:p>
@@ -2929,7 +2929,7 @@
                 </a:solidFill>
                 <a:latin typeface="Aptos"/>
               </a:rPr>
-              <a:t>Namjera splitova je mjeriti dvije stvari odvojeno: koliko model generalizira na nove rečenice istih govornika i koliko generalizira na potpuno neviđene govornike.</a:t>
+              <a:t>Namjera VEPRAD splitova je mjeriti dvije stvari odvojeno: koliko model generalizira na nove rečenice istih govornika i koliko generalizira na potpuno neviđene govornike.</a:t>
             </a:r>
             <a:endParaRPr lang="hr-HR" sz="1400"/>
           </a:p>
@@ -3109,30 +3109,30 @@
         <p:spPr>
           <a:xfrm>
             <a:off x="444500" y="520700"/>
-            <a:ext cx="7493000" cy="393700"/>
-          </a:xfrm>
-          <a:prstGeom prst="rect">
-            <a:avLst/>
-          </a:prstGeom>
-          <a:noFill/>
-          <a:ln>
-            <a:noFill/>
-          </a:ln>
-        </p:spPr>
-        <p:txBody>
-          <a:bodyPr wrap="square" lIns="0" tIns="0" rIns="0" bIns="0"/>
-          <a:lstStyle/>
-          <a:p>
-            <a:r>
-              <a:rPr lang="hr-HR" sz="2500" b="1">
+            <a:ext cx="7937500" cy="546100"/>
+          </a:xfrm>
+          <a:prstGeom prst="rect">
+            <a:avLst/>
+          </a:prstGeom>
+          <a:noFill/>
+          <a:ln>
+            <a:noFill/>
+          </a:ln>
+        </p:spPr>
+        <p:txBody>
+          <a:bodyPr wrap="square" lIns="0" tIns="0" rIns="0" bIns="0"/>
+          <a:lstStyle/>
+          <a:p>
+            <a:r>
+              <a:rPr lang="hr-HR" sz="2350" b="1">
                 <a:solidFill>
                   <a:srgbClr val="15171A"/>
                 </a:solidFill>
                 <a:latin typeface="Aptos"/>
               </a:rPr>
-              <a:t>Pipeline je sada jedan Python tok, ne stari shell recipe.</a:t>
-            </a:r>
-            <a:endParaRPr lang="hr-HR" sz="2500"/>
+              <a:t>VEPRAD pipeline je jedan Python tok, ne stari shell recipe.</a:t>
+            </a:r>
+            <a:endParaRPr lang="hr-HR" sz="2350"/>
           </a:p>
         </p:txBody>
       </p:sp>
@@ -3144,31 +3144,31 @@
         </p:nvSpPr>
         <p:spPr>
           <a:xfrm>
-            <a:off x="444500" y="952500"/>
-            <a:ext cx="7493000" cy="292100"/>
-          </a:xfrm>
-          <a:prstGeom prst="rect">
-            <a:avLst/>
-          </a:prstGeom>
-          <a:noFill/>
-          <a:ln>
-            <a:noFill/>
-          </a:ln>
-        </p:spPr>
-        <p:txBody>
-          <a:bodyPr wrap="square" lIns="0" tIns="0" rIns="0" bIns="0"/>
-          <a:lstStyle/>
-          <a:p>
-            <a:r>
-              <a:rPr lang="hr-HR" sz="1180">
+            <a:off x="444500" y="1130300"/>
+            <a:ext cx="7937500" cy="266700"/>
+          </a:xfrm>
+          <a:prstGeom prst="rect">
+            <a:avLst/>
+          </a:prstGeom>
+          <a:noFill/>
+          <a:ln>
+            <a:noFill/>
+          </a:ln>
+        </p:spPr>
+        <p:txBody>
+          <a:bodyPr wrap="square" lIns="0" tIns="0" rIns="0" bIns="0"/>
+          <a:lstStyle/>
+          <a:p>
+            <a:r>
+              <a:rPr lang="hr-HR" sz="1080">
                 <a:solidFill>
                   <a:srgbClr val="6F6A5B"/>
                 </a:solidFill>
                 <a:latin typeface="Aptos"/>
               </a:rPr>
-              <a:t>Skripta poziva PaddleSpeech Python funkcije direktno: split/manifesti, trening, averaging, eval i metrike.</a:t>
-            </a:r>
-            <a:endParaRPr lang="hr-HR" sz="1180"/>
+              <a:t>Skripta poziva PaddleSpeech Python funkcije direktno: VEPRAD split/manifesti, trening, averaging, eval i metrike.</a:t>
+            </a:r>
+            <a:endParaRPr lang="hr-HR" sz="1080"/>
           </a:p>
         </p:txBody>
       </p:sp>
@@ -3180,7 +3180,7 @@
         </p:nvSpPr>
         <p:spPr>
           <a:xfrm>
-            <a:off x="444500" y="1333500"/>
+            <a:off x="444500" y="1447800"/>
             <a:ext cx="736600" cy="44450"/>
           </a:xfrm>
           <a:prstGeom prst="rect">
@@ -4238,7 +4238,7 @@
                 </a:solidFill>
                 <a:latin typeface="Aptos"/>
               </a:rPr>
-              <a:t>Programski tok: scripts/run_ds2_pipeline.py generira PaddleSpeech podatke, trenira model, računa avg_1 checkpoint i evaluira val/test seen/unseen podskupove.</a:t>
+              <a:t>Programski tok: scripts/run_ds2_pipeline.py uzima VEPRAD manifest, generira PaddleSpeech podatke, trenira model, računa avg_1 checkpoint i evaluira VEPRAD val/test seen/unseen podskupove.</a:t>
             </a:r>
             <a:endParaRPr lang="hr-HR" sz="1350"/>
           </a:p>
@@ -4358,30 +4358,30 @@
         <p:spPr>
           <a:xfrm>
             <a:off x="444500" y="520700"/>
-            <a:ext cx="7493000" cy="393700"/>
-          </a:xfrm>
-          <a:prstGeom prst="rect">
-            <a:avLst/>
-          </a:prstGeom>
-          <a:noFill/>
-          <a:ln>
-            <a:noFill/>
-          </a:ln>
-        </p:spPr>
-        <p:txBody>
-          <a:bodyPr wrap="square" lIns="0" tIns="0" rIns="0" bIns="0"/>
-          <a:lstStyle/>
-          <a:p>
-            <a:r>
-              <a:rPr lang="hr-HR" sz="2500" b="1">
+            <a:ext cx="7937500" cy="546100"/>
+          </a:xfrm>
+          <a:prstGeom prst="rect">
+            <a:avLst/>
+          </a:prstGeom>
+          <a:noFill/>
+          <a:ln>
+            <a:noFill/>
+          </a:ln>
+        </p:spPr>
+        <p:txBody>
+          <a:bodyPr wrap="square" lIns="0" tIns="0" rIns="0" bIns="0"/>
+          <a:lstStyle/>
+          <a:p>
+            <a:r>
+              <a:rPr lang="hr-HR" sz="2350" b="1">
                 <a:solidFill>
                   <a:srgbClr val="15171A"/>
                 </a:solidFill>
                 <a:latin typeface="Aptos"/>
               </a:rPr>
-              <a:t>DeepSpeech2 pretvara akustičke značajke u vjerojatnosti znakova kroz CTC.</a:t>
-            </a:r>
-            <a:endParaRPr lang="hr-HR" sz="2500"/>
+              <a:t>DeepSpeech2 je akustički model koji smo trenirali na VEPRAD govoru.</a:t>
+            </a:r>
+            <a:endParaRPr lang="hr-HR" sz="2350"/>
           </a:p>
         </p:txBody>
       </p:sp>
@@ -4393,23 +4393,23 @@
         </p:nvSpPr>
         <p:spPr>
           <a:xfrm>
-            <a:off x="444500" y="952500"/>
-            <a:ext cx="7493000" cy="292100"/>
-          </a:xfrm>
-          <a:prstGeom prst="rect">
-            <a:avLst/>
-          </a:prstGeom>
-          <a:noFill/>
-          <a:ln>
-            <a:noFill/>
-          </a:ln>
-        </p:spPr>
-        <p:txBody>
-          <a:bodyPr wrap="square" lIns="0" tIns="0" rIns="0" bIns="0"/>
-          <a:lstStyle/>
-          <a:p>
-            <a:r>
-              <a:rPr lang="hr-HR" sz="1180">
+            <a:off x="444500" y="1130300"/>
+            <a:ext cx="7937500" cy="266700"/>
+          </a:xfrm>
+          <a:prstGeom prst="rect">
+            <a:avLst/>
+          </a:prstGeom>
+          <a:noFill/>
+          <a:ln>
+            <a:noFill/>
+          </a:ln>
+        </p:spPr>
+        <p:txBody>
+          <a:bodyPr wrap="square" lIns="0" tIns="0" rIns="0" bIns="0"/>
+          <a:lstStyle/>
+          <a:p>
+            <a:r>
+              <a:rPr lang="hr-HR" sz="1080">
                 <a:solidFill>
                   <a:srgbClr val="6F6A5B"/>
                 </a:solidFill>
@@ -4417,7 +4417,7 @@
               </a:rPr>
               <a:t>Slika prikazuje paper-style tok; desni stupac navodi što smo točno mogli reproducirati bez mijenjanja PaddleSpeech sourcea.</a:t>
             </a:r>
-            <a:endParaRPr lang="hr-HR" sz="1180"/>
+            <a:endParaRPr lang="hr-HR" sz="1080"/>
           </a:p>
         </p:txBody>
       </p:sp>
@@ -4429,7 +4429,7 @@
         </p:nvSpPr>
         <p:spPr>
           <a:xfrm>
-            <a:off x="444500" y="1333500"/>
+            <a:off x="444500" y="1447800"/>
             <a:ext cx="736600" cy="44450"/>
           </a:xfrm>
           <a:prstGeom prst="rect">
@@ -4733,7 +4733,7 @@
                 </a:solidFill>
                 <a:latin typeface="Aptos"/>
               </a:rPr>
-              <a:t>Zaključak: model je paper-close approximation, ne bit-for-bit reprodukcija Deep Speech 2 rada.</a:t>
+              <a:t>Zaključak: VEPRAD run je paper-close approximation, ne bit-for-bit reprodukcija Deep Speech 2 rada.</a:t>
             </a:r>
             <a:endParaRPr lang="hr-HR" sz="1350"/>
           </a:p>
@@ -4853,30 +4853,30 @@
         <p:spPr>
           <a:xfrm>
             <a:off x="444500" y="520700"/>
-            <a:ext cx="7493000" cy="393700"/>
-          </a:xfrm>
-          <a:prstGeom prst="rect">
-            <a:avLst/>
-          </a:prstGeom>
-          <a:noFill/>
-          <a:ln>
-            <a:noFill/>
-          </a:ln>
-        </p:spPr>
-        <p:txBody>
-          <a:bodyPr wrap="square" lIns="0" tIns="0" rIns="0" bIns="0"/>
-          <a:lstStyle/>
-          <a:p>
-            <a:r>
-              <a:rPr lang="hr-HR" sz="2500" b="1">
+            <a:ext cx="7937500" cy="546100"/>
+          </a:xfrm>
+          <a:prstGeom prst="rect">
+            <a:avLst/>
+          </a:prstGeom>
+          <a:noFill/>
+          <a:ln>
+            <a:noFill/>
+          </a:ln>
+        </p:spPr>
+        <p:txBody>
+          <a:bodyPr wrap="square" lIns="0" tIns="0" rIns="0" bIns="0"/>
+          <a:lstStyle/>
+          <a:p>
+            <a:r>
+              <a:rPr lang="hr-HR" sz="2350" b="1">
                 <a:solidFill>
                   <a:srgbClr val="15171A"/>
                 </a:solidFill>
                 <a:latin typeface="Aptos"/>
               </a:rPr>
-              <a:t>Trenirali smo paper-small konfiguraciju i dvije dublje varijante.</a:t>
-            </a:r>
-            <a:endParaRPr lang="hr-HR" sz="2500"/>
+              <a:t>Na istom VEPRAD splitu trenirali smo paper-small konfiguraciju i dvije dublje varijante.</a:t>
+            </a:r>
+            <a:endParaRPr lang="hr-HR" sz="2350"/>
           </a:p>
         </p:txBody>
       </p:sp>
@@ -4888,31 +4888,31 @@
         </p:nvSpPr>
         <p:spPr>
           <a:xfrm>
-            <a:off x="444500" y="952500"/>
-            <a:ext cx="7493000" cy="292100"/>
-          </a:xfrm>
-          <a:prstGeom prst="rect">
-            <a:avLst/>
-          </a:prstGeom>
-          <a:noFill/>
-          <a:ln>
-            <a:noFill/>
-          </a:ln>
-        </p:spPr>
-        <p:txBody>
-          <a:bodyPr wrap="square" lIns="0" tIns="0" rIns="0" bIns="0"/>
-          <a:lstStyle/>
-          <a:p>
-            <a:r>
-              <a:rPr lang="hr-HR" sz="1180">
+            <a:off x="444500" y="1130300"/>
+            <a:ext cx="7937500" cy="266700"/>
+          </a:xfrm>
+          <a:prstGeom prst="rect">
+            <a:avLst/>
+          </a:prstGeom>
+          <a:noFill/>
+          <a:ln>
+            <a:noFill/>
+          </a:ln>
+        </p:spPr>
+        <p:txBody>
+          <a:bodyPr wrap="square" lIns="0" tIns="0" rIns="0" bIns="0"/>
+          <a:lstStyle/>
+          <a:p>
+            <a:r>
+              <a:rPr lang="hr-HR" sz="1080">
                 <a:solidFill>
                   <a:srgbClr val="6F6A5B"/>
                 </a:solidFill>
                 <a:latin typeface="Aptos"/>
               </a:rPr>
-              <a:t>Cilj nije bio samo dobiti jedan score, nego vidjeti što se mijenja s dubinom i tipom rekurentne ćelije.</a:t>
-            </a:r>
-            <a:endParaRPr lang="hr-HR" sz="1180"/>
+              <a:t>Cilj nije bio samo dobiti jedan score, nego vidjeti što se na VEPRAD-u mijenja s dubinom i tipom rekurentne ćelije.</a:t>
+            </a:r>
+            <a:endParaRPr lang="hr-HR" sz="1080"/>
           </a:p>
         </p:txBody>
       </p:sp>
@@ -4924,7 +4924,7 @@
         </p:nvSpPr>
         <p:spPr>
           <a:xfrm>
-            <a:off x="444500" y="1333500"/>
+            <a:off x="444500" y="1447800"/>
             <a:ext cx="736600" cy="44450"/>
           </a:xfrm>
           <a:prstGeom prst="rect">
@@ -6280,7 +6280,7 @@
                 </a:solidFill>
                 <a:latin typeface="Aptos"/>
               </a:rPr>
-              <a:t>Paper-small run drži hidden size 650 i GRU kao najbližu izvedivu varijantu unutar PaddleSpeecha.</a:t>
+              <a:t>Paper-small run drži hidden size 650 i GRU kao najbližu izvedivu VEPRAD varijantu unutar PaddleSpeecha.</a:t>
             </a:r>
             <a:endParaRPr lang="hr-HR" sz="1350"/>
           </a:p>
@@ -6292,7 +6292,7 @@
                 </a:solidFill>
                 <a:latin typeface="Aptos"/>
               </a:rPr>
-              <a:t>Dublji GRU testira samu dubinu. LSTM testira je li druga recurrent cell bolja pod istim splitom i decoding protokolom.</a:t>
+              <a:t>Dublji GRU testira samu dubinu. LSTM testira je li druga recurrent cell bolja na istom VEPRAD splitu i decoding protokolu.</a:t>
             </a:r>
             <a:endParaRPr lang="hr-HR" sz="1350"/>
           </a:p>
@@ -6472,30 +6472,30 @@
         <p:spPr>
           <a:xfrm>
             <a:off x="444500" y="520700"/>
-            <a:ext cx="7493000" cy="393700"/>
-          </a:xfrm>
-          <a:prstGeom prst="rect">
-            <a:avLst/>
-          </a:prstGeom>
-          <a:noFill/>
-          <a:ln>
-            <a:noFill/>
-          </a:ln>
-        </p:spPr>
-        <p:txBody>
-          <a:bodyPr wrap="square" lIns="0" tIns="0" rIns="0" bIns="0"/>
-          <a:lstStyle/>
-          <a:p>
-            <a:r>
-              <a:rPr lang="hr-HR" sz="2500" b="1">
+            <a:ext cx="7937500" cy="546100"/>
+          </a:xfrm>
+          <a:prstGeom prst="rect">
+            <a:avLst/>
+          </a:prstGeom>
+          <a:noFill/>
+          <a:ln>
+            <a:noFill/>
+          </a:ln>
+        </p:spPr>
+        <p:txBody>
+          <a:bodyPr wrap="square" lIns="0" tIns="0" rIns="0" bIns="0"/>
+          <a:lstStyle/>
+          <a:p>
+            <a:r>
+              <a:rPr lang="hr-HR" sz="2350" b="1">
                 <a:solidFill>
                   <a:srgbClr val="15171A"/>
                 </a:solidFill>
                 <a:latin typeface="Aptos"/>
               </a:rPr>
-              <a:t>KenLM je vanjski word-level scorer koji dramatično pomaže na vremenskim prognozama.</a:t>
-            </a:r>
-            <a:endParaRPr lang="hr-HR" sz="2500"/>
+              <a:t>KenLM se trenira na VEPRAD train transkriptima.</a:t>
+            </a:r>
+            <a:endParaRPr lang="hr-HR" sz="2350"/>
           </a:p>
         </p:txBody>
       </p:sp>
@@ -6507,31 +6507,31 @@
         </p:nvSpPr>
         <p:spPr>
           <a:xfrm>
-            <a:off x="444500" y="952500"/>
-            <a:ext cx="7493000" cy="292100"/>
-          </a:xfrm>
-          <a:prstGeom prst="rect">
-            <a:avLst/>
-          </a:prstGeom>
-          <a:noFill/>
-          <a:ln>
-            <a:noFill/>
-          </a:ln>
-        </p:spPr>
-        <p:txBody>
-          <a:bodyPr wrap="square" lIns="0" tIns="0" rIns="0" bIns="0"/>
-          <a:lstStyle/>
-          <a:p>
-            <a:r>
-              <a:rPr lang="hr-HR" sz="1180">
+            <a:off x="444500" y="1130300"/>
+            <a:ext cx="7937500" cy="266700"/>
+          </a:xfrm>
+          <a:prstGeom prst="rect">
+            <a:avLst/>
+          </a:prstGeom>
+          <a:noFill/>
+          <a:ln>
+            <a:noFill/>
+          </a:ln>
+        </p:spPr>
+        <p:txBody>
+          <a:bodyPr wrap="square" lIns="0" tIns="0" rIns="0" bIns="0"/>
+          <a:lstStyle/>
+          <a:p>
+            <a:r>
+              <a:rPr lang="hr-HR" sz="1080">
                 <a:solidFill>
                   <a:srgbClr val="6F6A5B"/>
                 </a:solidFill>
                 <a:latin typeface="Aptos"/>
               </a:rPr>
-              <a:t>LM se trenira iz train transkripata, ali prije toga izbacujemo rečenice koje se previše poklapaju s val/test tekstom.</a:t>
-            </a:r>
-            <a:endParaRPr lang="hr-HR" sz="1180"/>
+              <a:t>Prije LM treninga izbacujemo VEPRAD train rečenice koje se previše poklapaju s val/test tekstom.</a:t>
+            </a:r>
+            <a:endParaRPr lang="hr-HR" sz="1080"/>
           </a:p>
         </p:txBody>
       </p:sp>
@@ -6543,7 +6543,7 @@
         </p:nvSpPr>
         <p:spPr>
           <a:xfrm>
-            <a:off x="444500" y="1333500"/>
+            <a:off x="444500" y="1447800"/>
             <a:ext cx="736600" cy="44450"/>
           </a:xfrm>
           <a:prstGeom prst="rect">
@@ -6932,7 +6932,7 @@
         <p:spPr>
           <a:xfrm>
             <a:off x="444500" y="3429000"/>
-            <a:ext cx="3302000" cy="190500"/>
+            <a:ext cx="3556000" cy="190500"/>
           </a:xfrm>
           <a:prstGeom prst="rect">
             <a:avLst/>
@@ -6953,7 +6953,7 @@
                 </a:solidFill>
                 <a:latin typeface="Aptos"/>
               </a:rPr>
-              <a:t>Najbolji validation-selected decoder</a:t>
+              <a:t>Najbolji VEPRAD decoder</a:t>
             </a:r>
             <a:endParaRPr lang="hr-HR" sz="1800"/>
           </a:p>
@@ -8123,30 +8123,30 @@
         <p:spPr>
           <a:xfrm>
             <a:off x="444500" y="520700"/>
-            <a:ext cx="7493000" cy="393700"/>
-          </a:xfrm>
-          <a:prstGeom prst="rect">
-            <a:avLst/>
-          </a:prstGeom>
-          <a:noFill/>
-          <a:ln>
-            <a:noFill/>
-          </a:ln>
-        </p:spPr>
-        <p:txBody>
-          <a:bodyPr wrap="square" lIns="0" tIns="0" rIns="0" bIns="0"/>
-          <a:lstStyle/>
-          <a:p>
-            <a:r>
-              <a:rPr lang="hr-HR" sz="2500" b="1">
+            <a:ext cx="7937500" cy="546100"/>
+          </a:xfrm>
+          <a:prstGeom prst="rect">
+            <a:avLst/>
+          </a:prstGeom>
+          <a:noFill/>
+          <a:ln>
+            <a:noFill/>
+          </a:ln>
+        </p:spPr>
+        <p:txBody>
+          <a:bodyPr wrap="square" lIns="0" tIns="0" rIns="0" bIns="0"/>
+          <a:lstStyle/>
+          <a:p>
+            <a:r>
+              <a:rPr lang="hr-HR" sz="2350" b="1">
                 <a:solidFill>
                   <a:srgbClr val="15171A"/>
                 </a:solidFill>
                 <a:latin typeface="Aptos"/>
               </a:rPr>
-              <a:t>Najbolji rezultat: paper-small GRU + KenLM.</a:t>
-            </a:r>
-            <a:endParaRPr lang="hr-HR" sz="2500"/>
+              <a:t>Najbolji VEPRAD rezultat: paper-small GRU + KenLM.</a:t>
+            </a:r>
+            <a:endParaRPr lang="hr-HR" sz="2350"/>
           </a:p>
         </p:txBody>
       </p:sp>
@@ -8158,31 +8158,31 @@
         </p:nvSpPr>
         <p:spPr>
           <a:xfrm>
-            <a:off x="444500" y="952500"/>
-            <a:ext cx="7493000" cy="292100"/>
-          </a:xfrm>
-          <a:prstGeom prst="rect">
-            <a:avLst/>
-          </a:prstGeom>
-          <a:noFill/>
-          <a:ln>
-            <a:noFill/>
-          </a:ln>
-        </p:spPr>
-        <p:txBody>
-          <a:bodyPr wrap="square" lIns="0" tIns="0" rIns="0" bIns="0"/>
-          <a:lstStyle/>
-          <a:p>
-            <a:r>
-              <a:rPr lang="hr-HR" sz="1180">
+            <a:off x="444500" y="1130300"/>
+            <a:ext cx="7937500" cy="266700"/>
+          </a:xfrm>
+          <a:prstGeom prst="rect">
+            <a:avLst/>
+          </a:prstGeom>
+          <a:noFill/>
+          <a:ln>
+            <a:noFill/>
+          </a:ln>
+        </p:spPr>
+        <p:txBody>
+          <a:bodyPr wrap="square" lIns="0" tIns="0" rIns="0" bIns="0"/>
+          <a:lstStyle/>
+          <a:p>
+            <a:r>
+              <a:rPr lang="hr-HR" sz="1080">
                 <a:solidFill>
                   <a:srgbClr val="6F6A5B"/>
                 </a:solidFill>
                 <a:latin typeface="Aptos"/>
               </a:rPr>
-              <a:t>Validation odabire beam 40; KenLM smanjuje WER nekoliko puta u odnosu na no-LM CTC decoding.</a:t>
-            </a:r>
-            <a:endParaRPr lang="hr-HR" sz="1180"/>
+              <a:t>VEPRAD validation odabire beam 40; KenLM smanjuje WER nekoliko puta u odnosu na no-LM CTC decoding.</a:t>
+            </a:r>
+            <a:endParaRPr lang="hr-HR" sz="1080"/>
           </a:p>
         </p:txBody>
       </p:sp>
@@ -8194,7 +8194,7 @@
         </p:nvSpPr>
         <p:spPr>
           <a:xfrm>
-            <a:off x="444500" y="1333500"/>
+            <a:off x="444500" y="1447800"/>
             <a:ext cx="736600" cy="44450"/>
           </a:xfrm>
           <a:prstGeom prst="rect">
@@ -9336,7 +9336,7 @@
                 </a:solidFill>
                 <a:latin typeface="Aptos"/>
               </a:rPr>
-              <a:t>Best model</a:t>
+              <a:t>Best VEPRAD model</a:t>
             </a:r>
             <a:endParaRPr lang="hr-HR" sz="1300"/>
           </a:p>
@@ -9466,7 +9466,7 @@
                 </a:solidFill>
                 <a:latin typeface="Aptos"/>
               </a:rPr>
-              <a:t>LM effect</a:t>
+              <a:t>VEPRAD LM effect</a:t>
             </a:r>
             <a:endParaRPr lang="hr-HR" sz="1300"/>
           </a:p>
@@ -9668,7 +9668,7 @@
                 </a:solidFill>
                 <a:latin typeface="Aptos"/>
               </a:rPr>
-              <a:t>seen vs unseen test WER</a:t>
+              <a:t>seen vs unseen VEPRAD</a:t>
             </a:r>
             <a:endParaRPr lang="hr-HR" sz="1050"/>
           </a:p>

</xml_diff>

<commit_message>
Add HF clean reproduction results slide
</commit_message>
<xml_diff>
--- a/presentation/ROGJ_Deepspeech2_topic_presentation.pptx
+++ b/presentation/ROGJ_Deepspeech2_topic_presentation.pptx
@@ -13,6 +13,7 @@
     <p:sldId id="261" r:id="rId7"/>
     <p:sldId id="262" r:id="rId8"/>
     <p:sldId id="263" r:id="rId9"/>
+    <p:sldId id="264" r:id="rId10"/>
   </p:sldIdLst>
   <p:sldSz cx="12192000" cy="6858000" type="wide"/>
   <p:notesSz cx="6858000" cy="9144000"/>
@@ -9624,6 +9625,2393 @@
 </file>
 
 <file path=ppt/slides/slide8.xml><?xml version="1.0" encoding="utf-8"?>
+<p:sld xmlns:a="http://schemas.openxmlformats.org/drawingml/2006/main" xmlns:r="http://schemas.openxmlformats.org/officeDocument/2006/relationships" xmlns:p="http://schemas.openxmlformats.org/presentationml/2006/main">
+  <p:cSld>
+    <p:bg>
+      <p:bgPr>
+        <a:solidFill>
+          <a:srgbClr val="F8F3E8"/>
+        </a:solidFill>
+        <a:effectLst/>
+      </p:bgPr>
+    </p:bg>
+    <p:spTree>
+      <p:nvGrpSpPr>
+        <p:cNvPr id="1" name=""/>
+        <p:cNvGrpSpPr/>
+        <p:nvPr/>
+      </p:nvGrpSpPr>
+      <p:grpSpPr>
+        <a:xfrm>
+          <a:off x="0" y="0"/>
+          <a:ext cx="0" cy="0"/>
+          <a:chOff x="0" y="0"/>
+          <a:chExt cx="0" cy="0"/>
+        </a:xfrm>
+      </p:grpSpPr>
+      <p:sp>
+        <p:nvSpPr>
+          <p:cNvPr id="2" name="Kicker"/>
+          <p:cNvSpPr txBox="1"/>
+          <p:nvPr/>
+        </p:nvSpPr>
+        <p:spPr>
+          <a:xfrm>
+            <a:off x="444500" y="292100"/>
+            <a:ext cx="3683000" cy="203200"/>
+          </a:xfrm>
+          <a:prstGeom prst="rect">
+            <a:avLst/>
+          </a:prstGeom>
+          <a:noFill/>
+          <a:ln>
+            <a:noFill/>
+          </a:ln>
+        </p:spPr>
+        <p:txBody>
+          <a:bodyPr wrap="square" lIns="0" tIns="0" rIns="0" bIns="0"/>
+          <a:lstStyle/>
+          <a:p>
+            <a:r>
+              <a:rPr lang="hr-HR" sz="1500" b="1">
+                <a:solidFill>
+                  <a:srgbClr val="E24A2A"/>
+                </a:solidFill>
+                <a:latin typeface="Aptos"/>
+              </a:rPr>
+              <a:t>08 · ČISTA HF REPRODUKCIJA</a:t>
+            </a:r>
+            <a:endParaRPr lang="hr-HR" sz="1500"/>
+          </a:p>
+        </p:txBody>
+      </p:sp>
+      <p:sp>
+        <p:nvSpPr>
+          <p:cNvPr id="3" name="Title"/>
+          <p:cNvSpPr txBox="1"/>
+          <p:nvPr/>
+        </p:nvSpPr>
+        <p:spPr>
+          <a:xfrm>
+            <a:off x="444500" y="520700"/>
+            <a:ext cx="7937500" cy="546100"/>
+          </a:xfrm>
+          <a:prstGeom prst="rect">
+            <a:avLst/>
+          </a:prstGeom>
+          <a:noFill/>
+          <a:ln>
+            <a:noFill/>
+          </a:ln>
+        </p:spPr>
+        <p:txBody>
+          <a:bodyPr wrap="square" lIns="0" tIns="0" rIns="0" bIns="0"/>
+          <a:lstStyle/>
+          <a:p>
+            <a:r>
+              <a:rPr lang="hr-HR" sz="2350" b="1">
+                <a:solidFill>
+                  <a:srgbClr val="15171A"/>
+                </a:solidFill>
+                <a:latin typeface="Aptos"/>
+              </a:rPr>
+              <a:t>Clean VEPRAD fine-tune reproducira 3.86% test WER.</a:t>
+            </a:r>
+            <a:endParaRPr lang="hr-HR" sz="2350"/>
+          </a:p>
+        </p:txBody>
+      </p:sp>
+      <p:sp>
+        <p:nvSpPr>
+          <p:cNvPr id="4" name="Support"/>
+          <p:cNvSpPr txBox="1"/>
+          <p:nvPr/>
+        </p:nvSpPr>
+        <p:spPr>
+          <a:xfrm>
+            <a:off x="444500" y="1130300"/>
+            <a:ext cx="7937500" cy="266700"/>
+          </a:xfrm>
+          <a:prstGeom prst="rect">
+            <a:avLst/>
+          </a:prstGeom>
+          <a:noFill/>
+          <a:ln>
+            <a:noFill/>
+          </a:ln>
+        </p:spPr>
+        <p:txBody>
+          <a:bodyPr wrap="square" lIns="0" tIns="0" rIns="0" bIns="0"/>
+          <a:lstStyle/>
+          <a:p>
+            <a:r>
+              <a:rPr lang="hr-HR" sz="1080">
+                <a:solidFill>
+                  <a:srgbClr val="6F6A5B"/>
+                </a:solidFill>
+                <a:latin typeface="Aptos"/>
+              </a:rPr>
+              <a:t>Zasebni HF/Wav2Vec2 run na istom clean split protokolu; nije PaddleSpeech/DeepSpeech2 trening.</a:t>
+            </a:r>
+            <a:endParaRPr lang="hr-HR" sz="1080"/>
+          </a:p>
+        </p:txBody>
+      </p:sp>
+      <p:sp>
+        <p:nvSpPr>
+          <p:cNvPr id="5" name="Rule"/>
+          <p:cNvSpPr/>
+          <p:nvPr/>
+        </p:nvSpPr>
+        <p:spPr>
+          <a:xfrm>
+            <a:off x="444500" y="1447800"/>
+            <a:ext cx="736600" cy="44450"/>
+          </a:xfrm>
+          <a:prstGeom prst="rect">
+            <a:avLst/>
+          </a:prstGeom>
+          <a:solidFill>
+            <a:srgbClr val="E24A2A"/>
+          </a:solidFill>
+          <a:ln>
+            <a:noFill/>
+          </a:ln>
+        </p:spPr>
+      </p:sp>
+      <p:sp>
+        <p:nvSpPr>
+          <p:cNvPr id="6" name="Rectangle"/>
+          <p:cNvSpPr/>
+          <p:nvPr/>
+        </p:nvSpPr>
+        <p:spPr>
+          <a:xfrm>
+            <a:off x="444500" y="1587500"/>
+            <a:ext cx="2667000" cy="920750"/>
+          </a:xfrm>
+          <a:prstGeom prst="rect">
+            <a:avLst/>
+          </a:prstGeom>
+          <a:solidFill>
+            <a:srgbClr val="15171A"/>
+          </a:solidFill>
+          <a:ln>
+            <a:noFill/>
+          </a:ln>
+        </p:spPr>
+      </p:sp>
+      <p:sp>
+        <p:nvSpPr>
+          <p:cNvPr id="7" name="Text"/>
+          <p:cNvSpPr txBox="1"/>
+          <p:nvPr/>
+        </p:nvSpPr>
+        <p:spPr>
+          <a:xfrm>
+            <a:off x="596900" y="1727200"/>
+            <a:ext cx="2286000" cy="152400"/>
+          </a:xfrm>
+          <a:prstGeom prst="rect">
+            <a:avLst/>
+          </a:prstGeom>
+          <a:noFill/>
+          <a:ln>
+            <a:noFill/>
+          </a:ln>
+        </p:spPr>
+        <p:txBody>
+          <a:bodyPr wrap="square" lIns="0" tIns="0" rIns="0" bIns="0"/>
+          <a:lstStyle/>
+          <a:p>
+            <a:r>
+              <a:rPr lang="hr-HR" sz="1300" b="1">
+                <a:solidFill>
+                  <a:srgbClr val="F8F3E8"/>
+                </a:solidFill>
+                <a:latin typeface="Aptos"/>
+              </a:rPr>
+              <a:t>Model</a:t>
+            </a:r>
+            <a:endParaRPr lang="hr-HR" sz="1300"/>
+          </a:p>
+        </p:txBody>
+      </p:sp>
+      <p:sp>
+        <p:nvSpPr>
+          <p:cNvPr id="8" name="Text"/>
+          <p:cNvSpPr txBox="1"/>
+          <p:nvPr/>
+        </p:nvSpPr>
+        <p:spPr>
+          <a:xfrm>
+            <a:off x="596900" y="1955800"/>
+            <a:ext cx="2286000" cy="177800"/>
+          </a:xfrm>
+          <a:prstGeom prst="rect">
+            <a:avLst/>
+          </a:prstGeom>
+          <a:noFill/>
+          <a:ln>
+            <a:noFill/>
+          </a:ln>
+        </p:spPr>
+        <p:txBody>
+          <a:bodyPr wrap="square" lIns="0" tIns="0" rIns="0" bIns="0"/>
+          <a:lstStyle/>
+          <a:p>
+            <a:r>
+              <a:rPr lang="hr-HR" sz="1500" b="1">
+                <a:solidFill>
+                  <a:srgbClr val="F8F3E8"/>
+                </a:solidFill>
+                <a:latin typeface="Aptos"/>
+              </a:rPr>
+              <a:t>CLASSLA Wav2Vec2</a:t>
+            </a:r>
+            <a:endParaRPr lang="hr-HR" sz="1500"/>
+          </a:p>
+        </p:txBody>
+      </p:sp>
+      <p:sp>
+        <p:nvSpPr>
+          <p:cNvPr id="9" name="Text"/>
+          <p:cNvSpPr txBox="1"/>
+          <p:nvPr/>
+        </p:nvSpPr>
+        <p:spPr>
+          <a:xfrm>
+            <a:off x="596900" y="2209800"/>
+            <a:ext cx="2286000" cy="215900"/>
+          </a:xfrm>
+          <a:prstGeom prst="rect">
+            <a:avLst/>
+          </a:prstGeom>
+          <a:noFill/>
+          <a:ln>
+            <a:noFill/>
+          </a:ln>
+        </p:spPr>
+        <p:txBody>
+          <a:bodyPr wrap="square" lIns="0" tIns="0" rIns="0" bIns="0"/>
+          <a:lstStyle/>
+          <a:p>
+            <a:r>
+              <a:rPr lang="hr-HR" sz="960">
+                <a:solidFill>
+                  <a:srgbClr val="F8F3E8"/>
+                </a:solidFill>
+                <a:latin typeface="Aptos"/>
+              </a:rPr>
+              <a:t>Large HR checkpoint + LM decoder</a:t>
+            </a:r>
+            <a:endParaRPr lang="hr-HR" sz="960"/>
+          </a:p>
+        </p:txBody>
+      </p:sp>
+      <p:sp>
+        <p:nvSpPr>
+          <p:cNvPr id="10" name="Rectangle"/>
+          <p:cNvSpPr/>
+          <p:nvPr/>
+        </p:nvSpPr>
+        <p:spPr>
+          <a:xfrm>
+            <a:off x="3587750" y="1587500"/>
+            <a:ext cx="2667000" cy="920750"/>
+          </a:xfrm>
+          <a:prstGeom prst="rect">
+            <a:avLst/>
+          </a:prstGeom>
+          <a:solidFill>
+            <a:srgbClr val="2C8C99"/>
+          </a:solidFill>
+          <a:ln>
+            <a:noFill/>
+          </a:ln>
+        </p:spPr>
+      </p:sp>
+      <p:sp>
+        <p:nvSpPr>
+          <p:cNvPr id="11" name="Text"/>
+          <p:cNvSpPr txBox="1"/>
+          <p:nvPr/>
+        </p:nvSpPr>
+        <p:spPr>
+          <a:xfrm>
+            <a:off x="3740150" y="1727200"/>
+            <a:ext cx="2286000" cy="152400"/>
+          </a:xfrm>
+          <a:prstGeom prst="rect">
+            <a:avLst/>
+          </a:prstGeom>
+          <a:noFill/>
+          <a:ln>
+            <a:noFill/>
+          </a:ln>
+        </p:spPr>
+        <p:txBody>
+          <a:bodyPr wrap="square" lIns="0" tIns="0" rIns="0" bIns="0"/>
+          <a:lstStyle/>
+          <a:p>
+            <a:r>
+              <a:rPr lang="hr-HR" sz="1300" b="1">
+                <a:solidFill>
+                  <a:srgbClr val="F8F3E8"/>
+                </a:solidFill>
+                <a:latin typeface="Aptos"/>
+              </a:rPr>
+              <a:t>Trening</a:t>
+            </a:r>
+            <a:endParaRPr lang="hr-HR" sz="1300"/>
+          </a:p>
+        </p:txBody>
+      </p:sp>
+      <p:sp>
+        <p:nvSpPr>
+          <p:cNvPr id="12" name="Text"/>
+          <p:cNvSpPr txBox="1"/>
+          <p:nvPr/>
+        </p:nvSpPr>
+        <p:spPr>
+          <a:xfrm>
+            <a:off x="3740150" y="1955800"/>
+            <a:ext cx="2286000" cy="177800"/>
+          </a:xfrm>
+          <a:prstGeom prst="rect">
+            <a:avLst/>
+          </a:prstGeom>
+          <a:noFill/>
+          <a:ln>
+            <a:noFill/>
+          </a:ln>
+        </p:spPr>
+        <p:txBody>
+          <a:bodyPr wrap="square" lIns="0" tIns="0" rIns="0" bIns="0"/>
+          <a:lstStyle/>
+          <a:p>
+            <a:r>
+              <a:rPr lang="hr-HR" sz="1500" b="1">
+                <a:solidFill>
+                  <a:srgbClr val="F8F3E8"/>
+                </a:solidFill>
+                <a:latin typeface="Aptos"/>
+              </a:rPr>
+              <a:t>8 epochs · 408 updates</a:t>
+            </a:r>
+            <a:endParaRPr lang="hr-HR" sz="1500"/>
+          </a:p>
+        </p:txBody>
+      </p:sp>
+      <p:sp>
+        <p:nvSpPr>
+          <p:cNvPr id="13" name="Text"/>
+          <p:cNvSpPr txBox="1"/>
+          <p:nvPr/>
+        </p:nvSpPr>
+        <p:spPr>
+          <a:xfrm>
+            <a:off x="3740150" y="2209800"/>
+            <a:ext cx="2286000" cy="215900"/>
+          </a:xfrm>
+          <a:prstGeom prst="rect">
+            <a:avLst/>
+          </a:prstGeom>
+          <a:noFill/>
+          <a:ln>
+            <a:noFill/>
+          </a:ln>
+        </p:spPr>
+        <p:txBody>
+          <a:bodyPr wrap="square" lIns="0" tIns="0" rIns="0" bIns="0"/>
+          <a:lstStyle/>
+          <a:p>
+            <a:r>
+              <a:rPr lang="hr-HR" sz="960">
+                <a:solidFill>
+                  <a:srgbClr val="F8F3E8"/>
+                </a:solidFill>
+                <a:latin typeface="Aptos"/>
+              </a:rPr>
+              <a:t>3298 train iskaza, 5.03 h, fp16, lr 3e-4</a:t>
+            </a:r>
+            <a:endParaRPr lang="hr-HR" sz="960"/>
+          </a:p>
+        </p:txBody>
+      </p:sp>
+      <p:sp>
+        <p:nvSpPr>
+          <p:cNvPr id="14" name="Rectangle"/>
+          <p:cNvSpPr/>
+          <p:nvPr/>
+        </p:nvSpPr>
+        <p:spPr>
+          <a:xfrm>
+            <a:off x="6731000" y="1587500"/>
+            <a:ext cx="2667000" cy="920750"/>
+          </a:xfrm>
+          <a:prstGeom prst="rect">
+            <a:avLst/>
+          </a:prstGeom>
+          <a:solidFill>
+            <a:srgbClr val="F0B429"/>
+          </a:solidFill>
+          <a:ln>
+            <a:noFill/>
+          </a:ln>
+        </p:spPr>
+      </p:sp>
+      <p:sp>
+        <p:nvSpPr>
+          <p:cNvPr id="15" name="Text"/>
+          <p:cNvSpPr txBox="1"/>
+          <p:nvPr/>
+        </p:nvSpPr>
+        <p:spPr>
+          <a:xfrm>
+            <a:off x="6883400" y="1727200"/>
+            <a:ext cx="2286000" cy="152400"/>
+          </a:xfrm>
+          <a:prstGeom prst="rect">
+            <a:avLst/>
+          </a:prstGeom>
+          <a:noFill/>
+          <a:ln>
+            <a:noFill/>
+          </a:ln>
+        </p:spPr>
+        <p:txBody>
+          <a:bodyPr wrap="square" lIns="0" tIns="0" rIns="0" bIns="0"/>
+          <a:lstStyle/>
+          <a:p>
+            <a:r>
+              <a:rPr lang="hr-HR" sz="1300" b="1">
+                <a:solidFill>
+                  <a:srgbClr val="15171A"/>
+                </a:solidFill>
+                <a:latin typeface="Aptos"/>
+              </a:rPr>
+              <a:t>Split</a:t>
+            </a:r>
+            <a:endParaRPr lang="hr-HR" sz="1300"/>
+          </a:p>
+        </p:txBody>
+      </p:sp>
+      <p:sp>
+        <p:nvSpPr>
+          <p:cNvPr id="16" name="Text"/>
+          <p:cNvSpPr txBox="1"/>
+          <p:nvPr/>
+        </p:nvSpPr>
+        <p:spPr>
+          <a:xfrm>
+            <a:off x="6883400" y="1955800"/>
+            <a:ext cx="2286000" cy="177800"/>
+          </a:xfrm>
+          <a:prstGeom prst="rect">
+            <a:avLst/>
+          </a:prstGeom>
+          <a:noFill/>
+          <a:ln>
+            <a:noFill/>
+          </a:ln>
+        </p:spPr>
+        <p:txBody>
+          <a:bodyPr wrap="square" lIns="0" tIns="0" rIns="0" bIns="0"/>
+          <a:lstStyle/>
+          <a:p>
+            <a:r>
+              <a:rPr lang="hr-HR" sz="1500" b="1">
+                <a:solidFill>
+                  <a:srgbClr val="15171A"/>
+                </a:solidFill>
+                <a:latin typeface="Aptos"/>
+              </a:rPr>
+              <a:t>clean CV + frozen test</a:t>
+            </a:r>
+            <a:endParaRPr lang="hr-HR" sz="1500"/>
+          </a:p>
+        </p:txBody>
+      </p:sp>
+      <p:sp>
+        <p:nvSpPr>
+          <p:cNvPr id="17" name="Text"/>
+          <p:cNvSpPr txBox="1"/>
+          <p:nvPr/>
+        </p:nvSpPr>
+        <p:spPr>
+          <a:xfrm>
+            <a:off x="6883400" y="2209800"/>
+            <a:ext cx="2286000" cy="215900"/>
+          </a:xfrm>
+          <a:prstGeom prst="rect">
+            <a:avLst/>
+          </a:prstGeom>
+          <a:noFill/>
+          <a:ln>
+            <a:noFill/>
+          </a:ln>
+        </p:spPr>
+        <p:txBody>
+          <a:bodyPr wrap="square" lIns="0" tIns="0" rIns="0" bIns="0"/>
+          <a:lstStyle/>
+          <a:p>
+            <a:r>
+              <a:rPr lang="hr-HR" sz="960">
+                <a:solidFill>
+                  <a:srgbClr val="15171A"/>
+                </a:solidFill>
+                <a:latin typeface="Aptos"/>
+              </a:rPr>
+              <a:t>val unseen: m05/m11/z07; test unseen: m04/z06/z14</a:t>
+            </a:r>
+            <a:endParaRPr lang="hr-HR" sz="960"/>
+          </a:p>
+        </p:txBody>
+      </p:sp>
+      <p:sp>
+        <p:nvSpPr>
+          <p:cNvPr id="18" name="Text"/>
+          <p:cNvSpPr txBox="1"/>
+          <p:nvPr/>
+        </p:nvSpPr>
+        <p:spPr>
+          <a:xfrm>
+            <a:off x="444500" y="2806700"/>
+            <a:ext cx="4064000" cy="190500"/>
+          </a:xfrm>
+          <a:prstGeom prst="rect">
+            <a:avLst/>
+          </a:prstGeom>
+          <a:noFill/>
+          <a:ln>
+            <a:noFill/>
+          </a:ln>
+        </p:spPr>
+        <p:txBody>
+          <a:bodyPr wrap="square" lIns="0" tIns="0" rIns="0" bIns="0"/>
+          <a:lstStyle/>
+          <a:p>
+            <a:r>
+              <a:rPr lang="hr-HR" sz="1800" b="1">
+                <a:solidFill>
+                  <a:srgbClr val="15171A"/>
+                </a:solidFill>
+                <a:latin typeface="Aptos"/>
+              </a:rPr>
+              <a:t>Validation + test rezultati</a:t>
+            </a:r>
+            <a:endParaRPr lang="hr-HR" sz="1800"/>
+          </a:p>
+        </p:txBody>
+      </p:sp>
+      <p:sp>
+        <p:nvSpPr>
+          <p:cNvPr id="19" name="Rule"/>
+          <p:cNvSpPr/>
+          <p:nvPr/>
+        </p:nvSpPr>
+        <p:spPr>
+          <a:xfrm>
+            <a:off x="444500" y="3048000"/>
+            <a:ext cx="571500" cy="38100"/>
+          </a:xfrm>
+          <a:prstGeom prst="rect">
+            <a:avLst/>
+          </a:prstGeom>
+          <a:solidFill>
+            <a:srgbClr val="E24A2A"/>
+          </a:solidFill>
+          <a:ln>
+            <a:noFill/>
+          </a:ln>
+        </p:spPr>
+      </p:sp>
+      <p:sp>
+        <p:nvSpPr>
+          <p:cNvPr id="20" name="Table background"/>
+          <p:cNvSpPr/>
+          <p:nvPr/>
+        </p:nvSpPr>
+        <p:spPr>
+          <a:xfrm>
+            <a:off x="444500" y="3270250"/>
+            <a:ext cx="8064500" cy="1778000"/>
+          </a:xfrm>
+          <a:prstGeom prst="rect">
+            <a:avLst/>
+          </a:prstGeom>
+          <a:solidFill>
+            <a:srgbClr val="F8F3E8"/>
+          </a:solidFill>
+          <a:ln w="12700">
+            <a:solidFill>
+              <a:srgbClr val="D6C8B5"/>
+            </a:solidFill>
+          </a:ln>
+        </p:spPr>
+      </p:sp>
+      <p:sp>
+        <p:nvSpPr>
+          <p:cNvPr id="21" name="Table header"/>
+          <p:cNvSpPr/>
+          <p:nvPr/>
+        </p:nvSpPr>
+        <p:spPr>
+          <a:xfrm>
+            <a:off x="444500" y="3270250"/>
+            <a:ext cx="8064500" cy="355600"/>
+          </a:xfrm>
+          <a:prstGeom prst="rect">
+            <a:avLst/>
+          </a:prstGeom>
+          <a:solidFill>
+            <a:srgbClr val="2C8C99"/>
+          </a:solidFill>
+          <a:ln>
+            <a:noFill/>
+          </a:ln>
+        </p:spPr>
+      </p:sp>
+      <p:sp>
+        <p:nvSpPr>
+          <p:cNvPr id="22" name="Table stripe"/>
+          <p:cNvSpPr/>
+          <p:nvPr/>
+        </p:nvSpPr>
+        <p:spPr>
+          <a:xfrm>
+            <a:off x="444500" y="3981450"/>
+            <a:ext cx="8064500" cy="355600"/>
+          </a:xfrm>
+          <a:prstGeom prst="rect">
+            <a:avLst/>
+          </a:prstGeom>
+          <a:solidFill>
+            <a:srgbClr val="F2DFC7"/>
+          </a:solidFill>
+          <a:ln>
+            <a:noFill/>
+          </a:ln>
+        </p:spPr>
+      </p:sp>
+      <p:sp>
+        <p:nvSpPr>
+          <p:cNvPr id="23" name="Table stripe"/>
+          <p:cNvSpPr/>
+          <p:nvPr/>
+        </p:nvSpPr>
+        <p:spPr>
+          <a:xfrm>
+            <a:off x="444500" y="4692650"/>
+            <a:ext cx="8064500" cy="355600"/>
+          </a:xfrm>
+          <a:prstGeom prst="rect">
+            <a:avLst/>
+          </a:prstGeom>
+          <a:solidFill>
+            <a:srgbClr val="F2DFC7"/>
+          </a:solidFill>
+          <a:ln>
+            <a:noFill/>
+          </a:ln>
+        </p:spPr>
+      </p:sp>
+      <p:sp>
+        <p:nvSpPr>
+          <p:cNvPr id="24" name="Header"/>
+          <p:cNvSpPr txBox="1"/>
+          <p:nvPr/>
+        </p:nvSpPr>
+        <p:spPr>
+          <a:xfrm>
+            <a:off x="495300" y="3327400"/>
+            <a:ext cx="1930400" cy="279400"/>
+          </a:xfrm>
+          <a:prstGeom prst="rect">
+            <a:avLst/>
+          </a:prstGeom>
+          <a:noFill/>
+          <a:ln>
+            <a:noFill/>
+          </a:ln>
+        </p:spPr>
+        <p:txBody>
+          <a:bodyPr wrap="square" lIns="0" tIns="0" rIns="0" bIns="0"/>
+          <a:lstStyle/>
+          <a:p>
+            <a:r>
+              <a:rPr lang="hr-HR" sz="900" b="1">
+                <a:solidFill>
+                  <a:srgbClr val="F8F3E8"/>
+                </a:solidFill>
+                <a:latin typeface="Aptos"/>
+              </a:rPr>
+              <a:t>Decoder</a:t>
+            </a:r>
+            <a:endParaRPr lang="hr-HR" sz="900"/>
+          </a:p>
+        </p:txBody>
+      </p:sp>
+      <p:sp>
+        <p:nvSpPr>
+          <p:cNvPr id="25" name="Header"/>
+          <p:cNvSpPr txBox="1"/>
+          <p:nvPr/>
+        </p:nvSpPr>
+        <p:spPr>
+          <a:xfrm>
+            <a:off x="2527300" y="3327400"/>
+            <a:ext cx="819150" cy="279400"/>
+          </a:xfrm>
+          <a:prstGeom prst="rect">
+            <a:avLst/>
+          </a:prstGeom>
+          <a:noFill/>
+          <a:ln>
+            <a:noFill/>
+          </a:ln>
+        </p:spPr>
+        <p:txBody>
+          <a:bodyPr wrap="square" lIns="0" tIns="0" rIns="0" bIns="0"/>
+          <a:lstStyle/>
+          <a:p>
+            <a:r>
+              <a:rPr lang="hr-HR" sz="900" b="1">
+                <a:solidFill>
+                  <a:srgbClr val="F8F3E8"/>
+                </a:solidFill>
+                <a:latin typeface="Aptos"/>
+              </a:rPr>
+              <a:t>Val WER</a:t>
+            </a:r>
+            <a:endParaRPr lang="hr-HR" sz="900"/>
+          </a:p>
+        </p:txBody>
+      </p:sp>
+      <p:sp>
+        <p:nvSpPr>
+          <p:cNvPr id="26" name="Header"/>
+          <p:cNvSpPr txBox="1"/>
+          <p:nvPr/>
+        </p:nvSpPr>
+        <p:spPr>
+          <a:xfrm>
+            <a:off x="3448050" y="3327400"/>
+            <a:ext cx="819150" cy="279400"/>
+          </a:xfrm>
+          <a:prstGeom prst="rect">
+            <a:avLst/>
+          </a:prstGeom>
+          <a:noFill/>
+          <a:ln>
+            <a:noFill/>
+          </a:ln>
+        </p:spPr>
+        <p:txBody>
+          <a:bodyPr wrap="square" lIns="0" tIns="0" rIns="0" bIns="0"/>
+          <a:lstStyle/>
+          <a:p>
+            <a:r>
+              <a:rPr lang="hr-HR" sz="900" b="1">
+                <a:solidFill>
+                  <a:srgbClr val="F8F3E8"/>
+                </a:solidFill>
+                <a:latin typeface="Aptos"/>
+              </a:rPr>
+              <a:t>Val CER</a:t>
+            </a:r>
+            <a:endParaRPr lang="hr-HR" sz="900"/>
+          </a:p>
+        </p:txBody>
+      </p:sp>
+      <p:sp>
+        <p:nvSpPr>
+          <p:cNvPr id="27" name="Header"/>
+          <p:cNvSpPr txBox="1"/>
+          <p:nvPr/>
+        </p:nvSpPr>
+        <p:spPr>
+          <a:xfrm>
+            <a:off x="4368800" y="3327400"/>
+            <a:ext cx="819150" cy="279400"/>
+          </a:xfrm>
+          <a:prstGeom prst="rect">
+            <a:avLst/>
+          </a:prstGeom>
+          <a:noFill/>
+          <a:ln>
+            <a:noFill/>
+          </a:ln>
+        </p:spPr>
+        <p:txBody>
+          <a:bodyPr wrap="square" lIns="0" tIns="0" rIns="0" bIns="0"/>
+          <a:lstStyle/>
+          <a:p>
+            <a:r>
+              <a:rPr lang="hr-HR" sz="900" b="1">
+                <a:solidFill>
+                  <a:srgbClr val="F8F3E8"/>
+                </a:solidFill>
+                <a:latin typeface="Aptos"/>
+              </a:rPr>
+              <a:t>Test WER</a:t>
+            </a:r>
+            <a:endParaRPr lang="hr-HR" sz="900"/>
+          </a:p>
+        </p:txBody>
+      </p:sp>
+      <p:sp>
+        <p:nvSpPr>
+          <p:cNvPr id="28" name="Header"/>
+          <p:cNvSpPr txBox="1"/>
+          <p:nvPr/>
+        </p:nvSpPr>
+        <p:spPr>
+          <a:xfrm>
+            <a:off x="5289550" y="3327400"/>
+            <a:ext cx="819150" cy="279400"/>
+          </a:xfrm>
+          <a:prstGeom prst="rect">
+            <a:avLst/>
+          </a:prstGeom>
+          <a:noFill/>
+          <a:ln>
+            <a:noFill/>
+          </a:ln>
+        </p:spPr>
+        <p:txBody>
+          <a:bodyPr wrap="square" lIns="0" tIns="0" rIns="0" bIns="0"/>
+          <a:lstStyle/>
+          <a:p>
+            <a:r>
+              <a:rPr lang="hr-HR" sz="900" b="1">
+                <a:solidFill>
+                  <a:srgbClr val="F8F3E8"/>
+                </a:solidFill>
+                <a:latin typeface="Aptos"/>
+              </a:rPr>
+              <a:t>Test CER</a:t>
+            </a:r>
+            <a:endParaRPr lang="hr-HR" sz="900"/>
+          </a:p>
+        </p:txBody>
+      </p:sp>
+      <p:sp>
+        <p:nvSpPr>
+          <p:cNvPr id="29" name="Header"/>
+          <p:cNvSpPr txBox="1"/>
+          <p:nvPr/>
+        </p:nvSpPr>
+        <p:spPr>
+          <a:xfrm>
+            <a:off x="6210300" y="3327400"/>
+            <a:ext cx="1073150" cy="279400"/>
+          </a:xfrm>
+          <a:prstGeom prst="rect">
+            <a:avLst/>
+          </a:prstGeom>
+          <a:noFill/>
+          <a:ln>
+            <a:noFill/>
+          </a:ln>
+        </p:spPr>
+        <p:txBody>
+          <a:bodyPr wrap="square" lIns="0" tIns="0" rIns="0" bIns="0"/>
+          <a:lstStyle/>
+          <a:p>
+            <a:r>
+              <a:rPr lang="hr-HR" sz="900" b="1">
+                <a:solidFill>
+                  <a:srgbClr val="F8F3E8"/>
+                </a:solidFill>
+                <a:latin typeface="Aptos"/>
+              </a:rPr>
+              <a:t>Test unseen WER</a:t>
+            </a:r>
+            <a:endParaRPr lang="hr-HR" sz="900"/>
+          </a:p>
+        </p:txBody>
+      </p:sp>
+      <p:sp>
+        <p:nvSpPr>
+          <p:cNvPr id="30" name="Header"/>
+          <p:cNvSpPr txBox="1"/>
+          <p:nvPr/>
+        </p:nvSpPr>
+        <p:spPr>
+          <a:xfrm>
+            <a:off x="7385050" y="3327400"/>
+            <a:ext cx="1073150" cy="279400"/>
+          </a:xfrm>
+          <a:prstGeom prst="rect">
+            <a:avLst/>
+          </a:prstGeom>
+          <a:noFill/>
+          <a:ln>
+            <a:noFill/>
+          </a:ln>
+        </p:spPr>
+        <p:txBody>
+          <a:bodyPr wrap="square" lIns="0" tIns="0" rIns="0" bIns="0"/>
+          <a:lstStyle/>
+          <a:p>
+            <a:r>
+              <a:rPr lang="hr-HR" sz="900" b="1">
+                <a:solidFill>
+                  <a:srgbClr val="F8F3E8"/>
+                </a:solidFill>
+                <a:latin typeface="Aptos"/>
+              </a:rPr>
+              <a:t>Test unseen CER</a:t>
+            </a:r>
+            <a:endParaRPr lang="hr-HR" sz="900"/>
+          </a:p>
+        </p:txBody>
+      </p:sp>
+      <p:sp>
+        <p:nvSpPr>
+          <p:cNvPr id="31" name="Cell"/>
+          <p:cNvSpPr txBox="1"/>
+          <p:nvPr/>
+        </p:nvSpPr>
+        <p:spPr>
+          <a:xfrm>
+            <a:off x="495300" y="3676650"/>
+            <a:ext cx="1930400" cy="292100"/>
+          </a:xfrm>
+          <a:prstGeom prst="rect">
+            <a:avLst/>
+          </a:prstGeom>
+          <a:noFill/>
+          <a:ln>
+            <a:noFill/>
+          </a:ln>
+        </p:spPr>
+        <p:txBody>
+          <a:bodyPr wrap="square" lIns="0" tIns="0" rIns="0" bIns="0"/>
+          <a:lstStyle/>
+          <a:p>
+            <a:r>
+              <a:rPr lang="hr-HR" sz="900" b="1">
+                <a:solidFill>
+                  <a:srgbClr val="15171A"/>
+                </a:solidFill>
+                <a:latin typeface="Aptos"/>
+              </a:rPr>
+              <a:t>pre-finetune greedy</a:t>
+            </a:r>
+            <a:endParaRPr lang="hr-HR" sz="900"/>
+          </a:p>
+        </p:txBody>
+      </p:sp>
+      <p:sp>
+        <p:nvSpPr>
+          <p:cNvPr id="32" name="Cell"/>
+          <p:cNvSpPr txBox="1"/>
+          <p:nvPr/>
+        </p:nvSpPr>
+        <p:spPr>
+          <a:xfrm>
+            <a:off x="2527300" y="3676650"/>
+            <a:ext cx="819150" cy="292100"/>
+          </a:xfrm>
+          <a:prstGeom prst="rect">
+            <a:avLst/>
+          </a:prstGeom>
+          <a:noFill/>
+          <a:ln>
+            <a:noFill/>
+          </a:ln>
+        </p:spPr>
+        <p:txBody>
+          <a:bodyPr wrap="square" lIns="0" tIns="0" rIns="0" bIns="0"/>
+          <a:lstStyle/>
+          <a:p>
+            <a:r>
+              <a:rPr lang="hr-HR" sz="900">
+                <a:solidFill>
+                  <a:srgbClr val="20282C"/>
+                </a:solidFill>
+                <a:latin typeface="Aptos"/>
+              </a:rPr>
+              <a:t>0.303</a:t>
+            </a:r>
+            <a:endParaRPr lang="hr-HR" sz="900"/>
+          </a:p>
+        </p:txBody>
+      </p:sp>
+      <p:sp>
+        <p:nvSpPr>
+          <p:cNvPr id="33" name="Cell"/>
+          <p:cNvSpPr txBox="1"/>
+          <p:nvPr/>
+        </p:nvSpPr>
+        <p:spPr>
+          <a:xfrm>
+            <a:off x="3448050" y="3676650"/>
+            <a:ext cx="819150" cy="292100"/>
+          </a:xfrm>
+          <a:prstGeom prst="rect">
+            <a:avLst/>
+          </a:prstGeom>
+          <a:noFill/>
+          <a:ln>
+            <a:noFill/>
+          </a:ln>
+        </p:spPr>
+        <p:txBody>
+          <a:bodyPr wrap="square" lIns="0" tIns="0" rIns="0" bIns="0"/>
+          <a:lstStyle/>
+          <a:p>
+            <a:r>
+              <a:rPr lang="hr-HR" sz="900">
+                <a:solidFill>
+                  <a:srgbClr val="20282C"/>
+                </a:solidFill>
+                <a:latin typeface="Aptos"/>
+              </a:rPr>
+              <a:t>0.149</a:t>
+            </a:r>
+            <a:endParaRPr lang="hr-HR" sz="900"/>
+          </a:p>
+        </p:txBody>
+      </p:sp>
+      <p:sp>
+        <p:nvSpPr>
+          <p:cNvPr id="34" name="Cell"/>
+          <p:cNvSpPr txBox="1"/>
+          <p:nvPr/>
+        </p:nvSpPr>
+        <p:spPr>
+          <a:xfrm>
+            <a:off x="4368800" y="3676650"/>
+            <a:ext cx="819150" cy="292100"/>
+          </a:xfrm>
+          <a:prstGeom prst="rect">
+            <a:avLst/>
+          </a:prstGeom>
+          <a:noFill/>
+          <a:ln>
+            <a:noFill/>
+          </a:ln>
+        </p:spPr>
+        <p:txBody>
+          <a:bodyPr wrap="square" lIns="0" tIns="0" rIns="0" bIns="0"/>
+          <a:lstStyle/>
+          <a:p>
+            <a:r>
+              <a:rPr lang="hr-HR" sz="900">
+                <a:solidFill>
+                  <a:srgbClr val="20282C"/>
+                </a:solidFill>
+                <a:latin typeface="Aptos"/>
+              </a:rPr>
+              <a:t>0.309</a:t>
+            </a:r>
+            <a:endParaRPr lang="hr-HR" sz="900"/>
+          </a:p>
+        </p:txBody>
+      </p:sp>
+      <p:sp>
+        <p:nvSpPr>
+          <p:cNvPr id="35" name="Cell"/>
+          <p:cNvSpPr txBox="1"/>
+          <p:nvPr/>
+        </p:nvSpPr>
+        <p:spPr>
+          <a:xfrm>
+            <a:off x="5289550" y="3676650"/>
+            <a:ext cx="819150" cy="292100"/>
+          </a:xfrm>
+          <a:prstGeom prst="rect">
+            <a:avLst/>
+          </a:prstGeom>
+          <a:noFill/>
+          <a:ln>
+            <a:noFill/>
+          </a:ln>
+        </p:spPr>
+        <p:txBody>
+          <a:bodyPr wrap="square" lIns="0" tIns="0" rIns="0" bIns="0"/>
+          <a:lstStyle/>
+          <a:p>
+            <a:r>
+              <a:rPr lang="hr-HR" sz="900">
+                <a:solidFill>
+                  <a:srgbClr val="20282C"/>
+                </a:solidFill>
+                <a:latin typeface="Aptos"/>
+              </a:rPr>
+              <a:t>0.154</a:t>
+            </a:r>
+            <a:endParaRPr lang="hr-HR" sz="900"/>
+          </a:p>
+        </p:txBody>
+      </p:sp>
+      <p:sp>
+        <p:nvSpPr>
+          <p:cNvPr id="36" name="Cell"/>
+          <p:cNvSpPr txBox="1"/>
+          <p:nvPr/>
+        </p:nvSpPr>
+        <p:spPr>
+          <a:xfrm>
+            <a:off x="6210300" y="3676650"/>
+            <a:ext cx="1073150" cy="292100"/>
+          </a:xfrm>
+          <a:prstGeom prst="rect">
+            <a:avLst/>
+          </a:prstGeom>
+          <a:noFill/>
+          <a:ln>
+            <a:noFill/>
+          </a:ln>
+        </p:spPr>
+        <p:txBody>
+          <a:bodyPr wrap="square" lIns="0" tIns="0" rIns="0" bIns="0"/>
+          <a:lstStyle/>
+          <a:p>
+            <a:r>
+              <a:rPr lang="hr-HR" sz="900">
+                <a:solidFill>
+                  <a:srgbClr val="20282C"/>
+                </a:solidFill>
+                <a:latin typeface="Aptos"/>
+              </a:rPr>
+              <a:t>0.337</a:t>
+            </a:r>
+            <a:endParaRPr lang="hr-HR" sz="900"/>
+          </a:p>
+        </p:txBody>
+      </p:sp>
+      <p:sp>
+        <p:nvSpPr>
+          <p:cNvPr id="37" name="Cell"/>
+          <p:cNvSpPr txBox="1"/>
+          <p:nvPr/>
+        </p:nvSpPr>
+        <p:spPr>
+          <a:xfrm>
+            <a:off x="7385050" y="3676650"/>
+            <a:ext cx="1073150" cy="292100"/>
+          </a:xfrm>
+          <a:prstGeom prst="rect">
+            <a:avLst/>
+          </a:prstGeom>
+          <a:noFill/>
+          <a:ln>
+            <a:noFill/>
+          </a:ln>
+        </p:spPr>
+        <p:txBody>
+          <a:bodyPr wrap="square" lIns="0" tIns="0" rIns="0" bIns="0"/>
+          <a:lstStyle/>
+          <a:p>
+            <a:r>
+              <a:rPr lang="hr-HR" sz="900">
+                <a:solidFill>
+                  <a:srgbClr val="20282C"/>
+                </a:solidFill>
+                <a:latin typeface="Aptos"/>
+              </a:rPr>
+              <a:t>0.169</a:t>
+            </a:r>
+            <a:endParaRPr lang="hr-HR" sz="900"/>
+          </a:p>
+        </p:txBody>
+      </p:sp>
+      <p:sp>
+        <p:nvSpPr>
+          <p:cNvPr id="38" name="Cell"/>
+          <p:cNvSpPr txBox="1"/>
+          <p:nvPr/>
+        </p:nvSpPr>
+        <p:spPr>
+          <a:xfrm>
+            <a:off x="495300" y="4032250"/>
+            <a:ext cx="1930400" cy="292100"/>
+          </a:xfrm>
+          <a:prstGeom prst="rect">
+            <a:avLst/>
+          </a:prstGeom>
+          <a:noFill/>
+          <a:ln>
+            <a:noFill/>
+          </a:ln>
+        </p:spPr>
+        <p:txBody>
+          <a:bodyPr wrap="square" lIns="0" tIns="0" rIns="0" bIns="0"/>
+          <a:lstStyle/>
+          <a:p>
+            <a:r>
+              <a:rPr lang="hr-HR" sz="900" b="1">
+                <a:solidFill>
+                  <a:srgbClr val="15171A"/>
+                </a:solidFill>
+                <a:latin typeface="Aptos"/>
+              </a:rPr>
+              <a:t>pre-finetune bundled LM</a:t>
+            </a:r>
+            <a:endParaRPr lang="hr-HR" sz="900"/>
+          </a:p>
+        </p:txBody>
+      </p:sp>
+      <p:sp>
+        <p:nvSpPr>
+          <p:cNvPr id="39" name="Cell"/>
+          <p:cNvSpPr txBox="1"/>
+          <p:nvPr/>
+        </p:nvSpPr>
+        <p:spPr>
+          <a:xfrm>
+            <a:off x="2527300" y="4032250"/>
+            <a:ext cx="819150" cy="292100"/>
+          </a:xfrm>
+          <a:prstGeom prst="rect">
+            <a:avLst/>
+          </a:prstGeom>
+          <a:noFill/>
+          <a:ln>
+            <a:noFill/>
+          </a:ln>
+        </p:spPr>
+        <p:txBody>
+          <a:bodyPr wrap="square" lIns="0" tIns="0" rIns="0" bIns="0"/>
+          <a:lstStyle/>
+          <a:p>
+            <a:r>
+              <a:rPr lang="hr-HR" sz="900">
+                <a:solidFill>
+                  <a:srgbClr val="20282C"/>
+                </a:solidFill>
+                <a:latin typeface="Aptos"/>
+              </a:rPr>
+              <a:t>0.284</a:t>
+            </a:r>
+            <a:endParaRPr lang="hr-HR" sz="900"/>
+          </a:p>
+        </p:txBody>
+      </p:sp>
+      <p:sp>
+        <p:nvSpPr>
+          <p:cNvPr id="40" name="Cell"/>
+          <p:cNvSpPr txBox="1"/>
+          <p:nvPr/>
+        </p:nvSpPr>
+        <p:spPr>
+          <a:xfrm>
+            <a:off x="3448050" y="4032250"/>
+            <a:ext cx="819150" cy="292100"/>
+          </a:xfrm>
+          <a:prstGeom prst="rect">
+            <a:avLst/>
+          </a:prstGeom>
+          <a:noFill/>
+          <a:ln>
+            <a:noFill/>
+          </a:ln>
+        </p:spPr>
+        <p:txBody>
+          <a:bodyPr wrap="square" lIns="0" tIns="0" rIns="0" bIns="0"/>
+          <a:lstStyle/>
+          <a:p>
+            <a:r>
+              <a:rPr lang="hr-HR" sz="900">
+                <a:solidFill>
+                  <a:srgbClr val="20282C"/>
+                </a:solidFill>
+                <a:latin typeface="Aptos"/>
+              </a:rPr>
+              <a:t>0.147</a:t>
+            </a:r>
+            <a:endParaRPr lang="hr-HR" sz="900"/>
+          </a:p>
+        </p:txBody>
+      </p:sp>
+      <p:sp>
+        <p:nvSpPr>
+          <p:cNvPr id="41" name="Cell"/>
+          <p:cNvSpPr txBox="1"/>
+          <p:nvPr/>
+        </p:nvSpPr>
+        <p:spPr>
+          <a:xfrm>
+            <a:off x="4368800" y="4032250"/>
+            <a:ext cx="819150" cy="292100"/>
+          </a:xfrm>
+          <a:prstGeom prst="rect">
+            <a:avLst/>
+          </a:prstGeom>
+          <a:noFill/>
+          <a:ln>
+            <a:noFill/>
+          </a:ln>
+        </p:spPr>
+        <p:txBody>
+          <a:bodyPr wrap="square" lIns="0" tIns="0" rIns="0" bIns="0"/>
+          <a:lstStyle/>
+          <a:p>
+            <a:r>
+              <a:rPr lang="hr-HR" sz="900">
+                <a:solidFill>
+                  <a:srgbClr val="20282C"/>
+                </a:solidFill>
+                <a:latin typeface="Aptos"/>
+              </a:rPr>
+              <a:t>0.294</a:t>
+            </a:r>
+            <a:endParaRPr lang="hr-HR" sz="900"/>
+          </a:p>
+        </p:txBody>
+      </p:sp>
+      <p:sp>
+        <p:nvSpPr>
+          <p:cNvPr id="42" name="Cell"/>
+          <p:cNvSpPr txBox="1"/>
+          <p:nvPr/>
+        </p:nvSpPr>
+        <p:spPr>
+          <a:xfrm>
+            <a:off x="5289550" y="4032250"/>
+            <a:ext cx="819150" cy="292100"/>
+          </a:xfrm>
+          <a:prstGeom prst="rect">
+            <a:avLst/>
+          </a:prstGeom>
+          <a:noFill/>
+          <a:ln>
+            <a:noFill/>
+          </a:ln>
+        </p:spPr>
+        <p:txBody>
+          <a:bodyPr wrap="square" lIns="0" tIns="0" rIns="0" bIns="0"/>
+          <a:lstStyle/>
+          <a:p>
+            <a:r>
+              <a:rPr lang="hr-HR" sz="900">
+                <a:solidFill>
+                  <a:srgbClr val="20282C"/>
+                </a:solidFill>
+                <a:latin typeface="Aptos"/>
+              </a:rPr>
+              <a:t>0.155</a:t>
+            </a:r>
+            <a:endParaRPr lang="hr-HR" sz="900"/>
+          </a:p>
+        </p:txBody>
+      </p:sp>
+      <p:sp>
+        <p:nvSpPr>
+          <p:cNvPr id="43" name="Cell"/>
+          <p:cNvSpPr txBox="1"/>
+          <p:nvPr/>
+        </p:nvSpPr>
+        <p:spPr>
+          <a:xfrm>
+            <a:off x="6210300" y="4032250"/>
+            <a:ext cx="1073150" cy="292100"/>
+          </a:xfrm>
+          <a:prstGeom prst="rect">
+            <a:avLst/>
+          </a:prstGeom>
+          <a:noFill/>
+          <a:ln>
+            <a:noFill/>
+          </a:ln>
+        </p:spPr>
+        <p:txBody>
+          <a:bodyPr wrap="square" lIns="0" tIns="0" rIns="0" bIns="0"/>
+          <a:lstStyle/>
+          <a:p>
+            <a:r>
+              <a:rPr lang="hr-HR" sz="900">
+                <a:solidFill>
+                  <a:srgbClr val="20282C"/>
+                </a:solidFill>
+                <a:latin typeface="Aptos"/>
+              </a:rPr>
+              <a:t>0.320</a:t>
+            </a:r>
+            <a:endParaRPr lang="hr-HR" sz="900"/>
+          </a:p>
+        </p:txBody>
+      </p:sp>
+      <p:sp>
+        <p:nvSpPr>
+          <p:cNvPr id="44" name="Cell"/>
+          <p:cNvSpPr txBox="1"/>
+          <p:nvPr/>
+        </p:nvSpPr>
+        <p:spPr>
+          <a:xfrm>
+            <a:off x="7385050" y="4032250"/>
+            <a:ext cx="1073150" cy="292100"/>
+          </a:xfrm>
+          <a:prstGeom prst="rect">
+            <a:avLst/>
+          </a:prstGeom>
+          <a:noFill/>
+          <a:ln>
+            <a:noFill/>
+          </a:ln>
+        </p:spPr>
+        <p:txBody>
+          <a:bodyPr wrap="square" lIns="0" tIns="0" rIns="0" bIns="0"/>
+          <a:lstStyle/>
+          <a:p>
+            <a:r>
+              <a:rPr lang="hr-HR" sz="900">
+                <a:solidFill>
+                  <a:srgbClr val="20282C"/>
+                </a:solidFill>
+                <a:latin typeface="Aptos"/>
+              </a:rPr>
+              <a:t>0.170</a:t>
+            </a:r>
+            <a:endParaRPr lang="hr-HR" sz="900"/>
+          </a:p>
+        </p:txBody>
+      </p:sp>
+      <p:sp>
+        <p:nvSpPr>
+          <p:cNvPr id="45" name="Cell"/>
+          <p:cNvSpPr txBox="1"/>
+          <p:nvPr/>
+        </p:nvSpPr>
+        <p:spPr>
+          <a:xfrm>
+            <a:off x="495300" y="4387850"/>
+            <a:ext cx="1930400" cy="292100"/>
+          </a:xfrm>
+          <a:prstGeom prst="rect">
+            <a:avLst/>
+          </a:prstGeom>
+          <a:noFill/>
+          <a:ln>
+            <a:noFill/>
+          </a:ln>
+        </p:spPr>
+        <p:txBody>
+          <a:bodyPr wrap="square" lIns="0" tIns="0" rIns="0" bIns="0"/>
+          <a:lstStyle/>
+          <a:p>
+            <a:r>
+              <a:rPr lang="hr-HR" sz="900" b="1">
+                <a:solidFill>
+                  <a:srgbClr val="15171A"/>
+                </a:solidFill>
+                <a:latin typeface="Aptos"/>
+              </a:rPr>
+              <a:t>fine-tuned greedy</a:t>
+            </a:r>
+            <a:endParaRPr lang="hr-HR" sz="900"/>
+          </a:p>
+        </p:txBody>
+      </p:sp>
+      <p:sp>
+        <p:nvSpPr>
+          <p:cNvPr id="46" name="Cell"/>
+          <p:cNvSpPr txBox="1"/>
+          <p:nvPr/>
+        </p:nvSpPr>
+        <p:spPr>
+          <a:xfrm>
+            <a:off x="2527300" y="4387850"/>
+            <a:ext cx="819150" cy="292100"/>
+          </a:xfrm>
+          <a:prstGeom prst="rect">
+            <a:avLst/>
+          </a:prstGeom>
+          <a:noFill/>
+          <a:ln>
+            <a:noFill/>
+          </a:ln>
+        </p:spPr>
+        <p:txBody>
+          <a:bodyPr wrap="square" lIns="0" tIns="0" rIns="0" bIns="0"/>
+          <a:lstStyle/>
+          <a:p>
+            <a:r>
+              <a:rPr lang="hr-HR" sz="900">
+                <a:solidFill>
+                  <a:srgbClr val="20282C"/>
+                </a:solidFill>
+                <a:latin typeface="Aptos"/>
+              </a:rPr>
+              <a:t>0.031</a:t>
+            </a:r>
+            <a:endParaRPr lang="hr-HR" sz="900"/>
+          </a:p>
+        </p:txBody>
+      </p:sp>
+      <p:sp>
+        <p:nvSpPr>
+          <p:cNvPr id="47" name="Cell"/>
+          <p:cNvSpPr txBox="1"/>
+          <p:nvPr/>
+        </p:nvSpPr>
+        <p:spPr>
+          <a:xfrm>
+            <a:off x="3448050" y="4387850"/>
+            <a:ext cx="819150" cy="292100"/>
+          </a:xfrm>
+          <a:prstGeom prst="rect">
+            <a:avLst/>
+          </a:prstGeom>
+          <a:noFill/>
+          <a:ln>
+            <a:noFill/>
+          </a:ln>
+        </p:spPr>
+        <p:txBody>
+          <a:bodyPr wrap="square" lIns="0" tIns="0" rIns="0" bIns="0"/>
+          <a:lstStyle/>
+          <a:p>
+            <a:r>
+              <a:rPr lang="hr-HR" sz="900">
+                <a:solidFill>
+                  <a:srgbClr val="20282C"/>
+                </a:solidFill>
+                <a:latin typeface="Aptos"/>
+              </a:rPr>
+              <a:t>0.008</a:t>
+            </a:r>
+            <a:endParaRPr lang="hr-HR" sz="900"/>
+          </a:p>
+        </p:txBody>
+      </p:sp>
+      <p:sp>
+        <p:nvSpPr>
+          <p:cNvPr id="48" name="Cell"/>
+          <p:cNvSpPr txBox="1"/>
+          <p:nvPr/>
+        </p:nvSpPr>
+        <p:spPr>
+          <a:xfrm>
+            <a:off x="4368800" y="4387850"/>
+            <a:ext cx="819150" cy="292100"/>
+          </a:xfrm>
+          <a:prstGeom prst="rect">
+            <a:avLst/>
+          </a:prstGeom>
+          <a:noFill/>
+          <a:ln>
+            <a:noFill/>
+          </a:ln>
+        </p:spPr>
+        <p:txBody>
+          <a:bodyPr wrap="square" lIns="0" tIns="0" rIns="0" bIns="0"/>
+          <a:lstStyle/>
+          <a:p>
+            <a:r>
+              <a:rPr lang="hr-HR" sz="900">
+                <a:solidFill>
+                  <a:srgbClr val="20282C"/>
+                </a:solidFill>
+                <a:latin typeface="Aptos"/>
+              </a:rPr>
+              <a:t>0.039</a:t>
+            </a:r>
+            <a:endParaRPr lang="hr-HR" sz="900"/>
+          </a:p>
+        </p:txBody>
+      </p:sp>
+      <p:sp>
+        <p:nvSpPr>
+          <p:cNvPr id="49" name="Cell"/>
+          <p:cNvSpPr txBox="1"/>
+          <p:nvPr/>
+        </p:nvSpPr>
+        <p:spPr>
+          <a:xfrm>
+            <a:off x="5289550" y="4387850"/>
+            <a:ext cx="819150" cy="292100"/>
+          </a:xfrm>
+          <a:prstGeom prst="rect">
+            <a:avLst/>
+          </a:prstGeom>
+          <a:noFill/>
+          <a:ln>
+            <a:noFill/>
+          </a:ln>
+        </p:spPr>
+        <p:txBody>
+          <a:bodyPr wrap="square" lIns="0" tIns="0" rIns="0" bIns="0"/>
+          <a:lstStyle/>
+          <a:p>
+            <a:r>
+              <a:rPr lang="hr-HR" sz="900">
+                <a:solidFill>
+                  <a:srgbClr val="20282C"/>
+                </a:solidFill>
+                <a:latin typeface="Aptos"/>
+              </a:rPr>
+              <a:t>0.008</a:t>
+            </a:r>
+            <a:endParaRPr lang="hr-HR" sz="900"/>
+          </a:p>
+        </p:txBody>
+      </p:sp>
+      <p:sp>
+        <p:nvSpPr>
+          <p:cNvPr id="50" name="Cell"/>
+          <p:cNvSpPr txBox="1"/>
+          <p:nvPr/>
+        </p:nvSpPr>
+        <p:spPr>
+          <a:xfrm>
+            <a:off x="6210300" y="4387850"/>
+            <a:ext cx="1073150" cy="292100"/>
+          </a:xfrm>
+          <a:prstGeom prst="rect">
+            <a:avLst/>
+          </a:prstGeom>
+          <a:noFill/>
+          <a:ln>
+            <a:noFill/>
+          </a:ln>
+        </p:spPr>
+        <p:txBody>
+          <a:bodyPr wrap="square" lIns="0" tIns="0" rIns="0" bIns="0"/>
+          <a:lstStyle/>
+          <a:p>
+            <a:r>
+              <a:rPr lang="hr-HR" sz="900">
+                <a:solidFill>
+                  <a:srgbClr val="20282C"/>
+                </a:solidFill>
+                <a:latin typeface="Aptos"/>
+              </a:rPr>
+              <a:t>0.050</a:t>
+            </a:r>
+            <a:endParaRPr lang="hr-HR" sz="900"/>
+          </a:p>
+        </p:txBody>
+      </p:sp>
+      <p:sp>
+        <p:nvSpPr>
+          <p:cNvPr id="51" name="Cell"/>
+          <p:cNvSpPr txBox="1"/>
+          <p:nvPr/>
+        </p:nvSpPr>
+        <p:spPr>
+          <a:xfrm>
+            <a:off x="7385050" y="4387850"/>
+            <a:ext cx="1073150" cy="292100"/>
+          </a:xfrm>
+          <a:prstGeom prst="rect">
+            <a:avLst/>
+          </a:prstGeom>
+          <a:noFill/>
+          <a:ln>
+            <a:noFill/>
+          </a:ln>
+        </p:spPr>
+        <p:txBody>
+          <a:bodyPr wrap="square" lIns="0" tIns="0" rIns="0" bIns="0"/>
+          <a:lstStyle/>
+          <a:p>
+            <a:r>
+              <a:rPr lang="hr-HR" sz="900">
+                <a:solidFill>
+                  <a:srgbClr val="20282C"/>
+                </a:solidFill>
+                <a:latin typeface="Aptos"/>
+              </a:rPr>
+              <a:t>0.010</a:t>
+            </a:r>
+            <a:endParaRPr lang="hr-HR" sz="900"/>
+          </a:p>
+        </p:txBody>
+      </p:sp>
+      <p:sp>
+        <p:nvSpPr>
+          <p:cNvPr id="52" name="Cell"/>
+          <p:cNvSpPr txBox="1"/>
+          <p:nvPr/>
+        </p:nvSpPr>
+        <p:spPr>
+          <a:xfrm>
+            <a:off x="495300" y="4743450"/>
+            <a:ext cx="1930400" cy="292100"/>
+          </a:xfrm>
+          <a:prstGeom prst="rect">
+            <a:avLst/>
+          </a:prstGeom>
+          <a:noFill/>
+          <a:ln>
+            <a:noFill/>
+          </a:ln>
+        </p:spPr>
+        <p:txBody>
+          <a:bodyPr wrap="square" lIns="0" tIns="0" rIns="0" bIns="0"/>
+          <a:lstStyle/>
+          <a:p>
+            <a:r>
+              <a:rPr lang="hr-HR" sz="900" b="1">
+                <a:solidFill>
+                  <a:srgbClr val="15171A"/>
+                </a:solidFill>
+                <a:latin typeface="Aptos"/>
+              </a:rPr>
+              <a:t>fine-tuned bundled LM</a:t>
+            </a:r>
+            <a:endParaRPr lang="hr-HR" sz="900"/>
+          </a:p>
+        </p:txBody>
+      </p:sp>
+      <p:sp>
+        <p:nvSpPr>
+          <p:cNvPr id="53" name="Cell"/>
+          <p:cNvSpPr txBox="1"/>
+          <p:nvPr/>
+        </p:nvSpPr>
+        <p:spPr>
+          <a:xfrm>
+            <a:off x="2527300" y="4743450"/>
+            <a:ext cx="819150" cy="292100"/>
+          </a:xfrm>
+          <a:prstGeom prst="rect">
+            <a:avLst/>
+          </a:prstGeom>
+          <a:noFill/>
+          <a:ln>
+            <a:noFill/>
+          </a:ln>
+        </p:spPr>
+        <p:txBody>
+          <a:bodyPr wrap="square" lIns="0" tIns="0" rIns="0" bIns="0"/>
+          <a:lstStyle/>
+          <a:p>
+            <a:r>
+              <a:rPr lang="hr-HR" sz="900">
+                <a:solidFill>
+                  <a:srgbClr val="20282C"/>
+                </a:solidFill>
+                <a:latin typeface="Aptos"/>
+              </a:rPr>
+              <a:t>0.037</a:t>
+            </a:r>
+            <a:endParaRPr lang="hr-HR" sz="900"/>
+          </a:p>
+        </p:txBody>
+      </p:sp>
+      <p:sp>
+        <p:nvSpPr>
+          <p:cNvPr id="54" name="Cell"/>
+          <p:cNvSpPr txBox="1"/>
+          <p:nvPr/>
+        </p:nvSpPr>
+        <p:spPr>
+          <a:xfrm>
+            <a:off x="3448050" y="4743450"/>
+            <a:ext cx="819150" cy="292100"/>
+          </a:xfrm>
+          <a:prstGeom prst="rect">
+            <a:avLst/>
+          </a:prstGeom>
+          <a:noFill/>
+          <a:ln>
+            <a:noFill/>
+          </a:ln>
+        </p:spPr>
+        <p:txBody>
+          <a:bodyPr wrap="square" lIns="0" tIns="0" rIns="0" bIns="0"/>
+          <a:lstStyle/>
+          <a:p>
+            <a:r>
+              <a:rPr lang="hr-HR" sz="900">
+                <a:solidFill>
+                  <a:srgbClr val="20282C"/>
+                </a:solidFill>
+                <a:latin typeface="Aptos"/>
+              </a:rPr>
+              <a:t>0.010</a:t>
+            </a:r>
+            <a:endParaRPr lang="hr-HR" sz="900"/>
+          </a:p>
+        </p:txBody>
+      </p:sp>
+      <p:sp>
+        <p:nvSpPr>
+          <p:cNvPr id="55" name="Cell"/>
+          <p:cNvSpPr txBox="1"/>
+          <p:nvPr/>
+        </p:nvSpPr>
+        <p:spPr>
+          <a:xfrm>
+            <a:off x="4368800" y="4743450"/>
+            <a:ext cx="819150" cy="292100"/>
+          </a:xfrm>
+          <a:prstGeom prst="rect">
+            <a:avLst/>
+          </a:prstGeom>
+          <a:noFill/>
+          <a:ln>
+            <a:noFill/>
+          </a:ln>
+        </p:spPr>
+        <p:txBody>
+          <a:bodyPr wrap="square" lIns="0" tIns="0" rIns="0" bIns="0"/>
+          <a:lstStyle/>
+          <a:p>
+            <a:r>
+              <a:rPr lang="hr-HR" sz="900">
+                <a:solidFill>
+                  <a:srgbClr val="20282C"/>
+                </a:solidFill>
+                <a:latin typeface="Aptos"/>
+              </a:rPr>
+              <a:t>0.042</a:t>
+            </a:r>
+            <a:endParaRPr lang="hr-HR" sz="900"/>
+          </a:p>
+        </p:txBody>
+      </p:sp>
+      <p:sp>
+        <p:nvSpPr>
+          <p:cNvPr id="56" name="Cell"/>
+          <p:cNvSpPr txBox="1"/>
+          <p:nvPr/>
+        </p:nvSpPr>
+        <p:spPr>
+          <a:xfrm>
+            <a:off x="5289550" y="4743450"/>
+            <a:ext cx="819150" cy="292100"/>
+          </a:xfrm>
+          <a:prstGeom prst="rect">
+            <a:avLst/>
+          </a:prstGeom>
+          <a:noFill/>
+          <a:ln>
+            <a:noFill/>
+          </a:ln>
+        </p:spPr>
+        <p:txBody>
+          <a:bodyPr wrap="square" lIns="0" tIns="0" rIns="0" bIns="0"/>
+          <a:lstStyle/>
+          <a:p>
+            <a:r>
+              <a:rPr lang="hr-HR" sz="900">
+                <a:solidFill>
+                  <a:srgbClr val="20282C"/>
+                </a:solidFill>
+                <a:latin typeface="Aptos"/>
+              </a:rPr>
+              <a:t>0.009</a:t>
+            </a:r>
+            <a:endParaRPr lang="hr-HR" sz="900"/>
+          </a:p>
+        </p:txBody>
+      </p:sp>
+      <p:sp>
+        <p:nvSpPr>
+          <p:cNvPr id="57" name="Cell"/>
+          <p:cNvSpPr txBox="1"/>
+          <p:nvPr/>
+        </p:nvSpPr>
+        <p:spPr>
+          <a:xfrm>
+            <a:off x="6210300" y="4743450"/>
+            <a:ext cx="1073150" cy="292100"/>
+          </a:xfrm>
+          <a:prstGeom prst="rect">
+            <a:avLst/>
+          </a:prstGeom>
+          <a:noFill/>
+          <a:ln>
+            <a:noFill/>
+          </a:ln>
+        </p:spPr>
+        <p:txBody>
+          <a:bodyPr wrap="square" lIns="0" tIns="0" rIns="0" bIns="0"/>
+          <a:lstStyle/>
+          <a:p>
+            <a:r>
+              <a:rPr lang="hr-HR" sz="900">
+                <a:solidFill>
+                  <a:srgbClr val="20282C"/>
+                </a:solidFill>
+                <a:latin typeface="Aptos"/>
+              </a:rPr>
+              <a:t>0.051</a:t>
+            </a:r>
+            <a:endParaRPr lang="hr-HR" sz="900"/>
+          </a:p>
+        </p:txBody>
+      </p:sp>
+      <p:sp>
+        <p:nvSpPr>
+          <p:cNvPr id="58" name="Cell"/>
+          <p:cNvSpPr txBox="1"/>
+          <p:nvPr/>
+        </p:nvSpPr>
+        <p:spPr>
+          <a:xfrm>
+            <a:off x="7385050" y="4743450"/>
+            <a:ext cx="1073150" cy="292100"/>
+          </a:xfrm>
+          <a:prstGeom prst="rect">
+            <a:avLst/>
+          </a:prstGeom>
+          <a:noFill/>
+          <a:ln>
+            <a:noFill/>
+          </a:ln>
+        </p:spPr>
+        <p:txBody>
+          <a:bodyPr wrap="square" lIns="0" tIns="0" rIns="0" bIns="0"/>
+          <a:lstStyle/>
+          <a:p>
+            <a:r>
+              <a:rPr lang="hr-HR" sz="900">
+                <a:solidFill>
+                  <a:srgbClr val="20282C"/>
+                </a:solidFill>
+                <a:latin typeface="Aptos"/>
+              </a:rPr>
+              <a:t>0.011</a:t>
+            </a:r>
+            <a:endParaRPr lang="hr-HR" sz="900"/>
+          </a:p>
+        </p:txBody>
+      </p:sp>
+      <p:sp>
+        <p:nvSpPr>
+          <p:cNvPr id="59" name="Text"/>
+          <p:cNvSpPr txBox="1"/>
+          <p:nvPr/>
+        </p:nvSpPr>
+        <p:spPr>
+          <a:xfrm>
+            <a:off x="444500" y="4953000"/>
+            <a:ext cx="8636000" cy="215900"/>
+          </a:xfrm>
+          <a:prstGeom prst="rect">
+            <a:avLst/>
+          </a:prstGeom>
+          <a:noFill/>
+          <a:ln>
+            <a:noFill/>
+          </a:ln>
+        </p:spPr>
+        <p:txBody>
+          <a:bodyPr wrap="square" lIns="0" tIns="0" rIns="0" bIns="0"/>
+          <a:lstStyle/>
+          <a:p>
+            <a:r>
+              <a:rPr lang="hr-HR" sz="1150">
+                <a:solidFill>
+                  <a:srgbClr val="6F6A5B"/>
+                </a:solidFill>
+                <a:latin typeface="Aptos"/>
+              </a:rPr>
+              <a:t>CER je prikazan bez razmaka. Bundled LM je fiksni eksterni ParlaMint LM iz checkpointa; ne treniramo VEPRAD KenLM, pa nema text-only LM curenja iz traina prema val/testu.</a:t>
+            </a:r>
+            <a:endParaRPr lang="hr-HR" sz="1150"/>
+          </a:p>
+        </p:txBody>
+      </p:sp>
+      <p:sp>
+        <p:nvSpPr>
+          <p:cNvPr id="60" name="Rectangle"/>
+          <p:cNvSpPr/>
+          <p:nvPr/>
+        </p:nvSpPr>
+        <p:spPr>
+          <a:xfrm>
+            <a:off x="571500" y="5365750"/>
+            <a:ext cx="2476500" cy="666750"/>
+          </a:xfrm>
+          <a:prstGeom prst="rect">
+            <a:avLst/>
+          </a:prstGeom>
+          <a:solidFill>
+            <a:srgbClr val="E24A2A"/>
+          </a:solidFill>
+          <a:ln>
+            <a:noFill/>
+          </a:ln>
+        </p:spPr>
+      </p:sp>
+      <p:sp>
+        <p:nvSpPr>
+          <p:cNvPr id="61" name="Text"/>
+          <p:cNvSpPr txBox="1"/>
+          <p:nvPr/>
+        </p:nvSpPr>
+        <p:spPr>
+          <a:xfrm>
+            <a:off x="723900" y="5473700"/>
+            <a:ext cx="2095500" cy="139700"/>
+          </a:xfrm>
+          <a:prstGeom prst="rect">
+            <a:avLst/>
+          </a:prstGeom>
+          <a:noFill/>
+          <a:ln>
+            <a:noFill/>
+          </a:ln>
+        </p:spPr>
+        <p:txBody>
+          <a:bodyPr wrap="square" lIns="0" tIns="0" rIns="0" bIns="0"/>
+          <a:lstStyle/>
+          <a:p>
+            <a:r>
+              <a:rPr lang="hr-HR" sz="1250" b="1">
+                <a:solidFill>
+                  <a:srgbClr val="F8F3E8"/>
+                </a:solidFill>
+                <a:latin typeface="Aptos"/>
+              </a:rPr>
+              <a:t>Najbolji full test</a:t>
+            </a:r>
+            <a:endParaRPr lang="hr-HR" sz="1250"/>
+          </a:p>
+        </p:txBody>
+      </p:sp>
+      <p:sp>
+        <p:nvSpPr>
+          <p:cNvPr id="62" name="Text"/>
+          <p:cNvSpPr txBox="1"/>
+          <p:nvPr/>
+        </p:nvSpPr>
+        <p:spPr>
+          <a:xfrm>
+            <a:off x="723900" y="5651500"/>
+            <a:ext cx="2095500" cy="177800"/>
+          </a:xfrm>
+          <a:prstGeom prst="rect">
+            <a:avLst/>
+          </a:prstGeom>
+          <a:noFill/>
+          <a:ln>
+            <a:noFill/>
+          </a:ln>
+        </p:spPr>
+        <p:txBody>
+          <a:bodyPr wrap="square" lIns="0" tIns="0" rIns="0" bIns="0"/>
+          <a:lstStyle/>
+          <a:p>
+            <a:r>
+              <a:rPr lang="hr-HR" sz="1650" b="1">
+                <a:solidFill>
+                  <a:srgbClr val="F8F3E8"/>
+                </a:solidFill>
+                <a:latin typeface="Aptos"/>
+              </a:rPr>
+              <a:t>greedy fine-tuned</a:t>
+            </a:r>
+            <a:endParaRPr lang="hr-HR" sz="1650"/>
+          </a:p>
+        </p:txBody>
+      </p:sp>
+      <p:sp>
+        <p:nvSpPr>
+          <p:cNvPr id="63" name="Text"/>
+          <p:cNvSpPr txBox="1"/>
+          <p:nvPr/>
+        </p:nvSpPr>
+        <p:spPr>
+          <a:xfrm>
+            <a:off x="723900" y="5854700"/>
+            <a:ext cx="2095500" cy="127000"/>
+          </a:xfrm>
+          <a:prstGeom prst="rect">
+            <a:avLst/>
+          </a:prstGeom>
+          <a:noFill/>
+          <a:ln>
+            <a:noFill/>
+          </a:ln>
+        </p:spPr>
+        <p:txBody>
+          <a:bodyPr wrap="square" lIns="0" tIns="0" rIns="0" bIns="0"/>
+          <a:lstStyle/>
+          <a:p>
+            <a:r>
+              <a:rPr lang="hr-HR" sz="1050">
+                <a:solidFill>
+                  <a:srgbClr val="F8F3E8"/>
+                </a:solidFill>
+                <a:latin typeface="Aptos"/>
+              </a:rPr>
+              <a:t>3.86% WER · 0.75% CER</a:t>
+            </a:r>
+            <a:endParaRPr lang="hr-HR" sz="1050"/>
+          </a:p>
+        </p:txBody>
+      </p:sp>
+      <p:sp>
+        <p:nvSpPr>
+          <p:cNvPr id="64" name="Rectangle"/>
+          <p:cNvSpPr/>
+          <p:nvPr/>
+        </p:nvSpPr>
+        <p:spPr>
+          <a:xfrm>
+            <a:off x="3302000" y="5365750"/>
+            <a:ext cx="2476500" cy="666750"/>
+          </a:xfrm>
+          <a:prstGeom prst="rect">
+            <a:avLst/>
+          </a:prstGeom>
+          <a:solidFill>
+            <a:srgbClr val="2C8C99"/>
+          </a:solidFill>
+          <a:ln>
+            <a:noFill/>
+          </a:ln>
+        </p:spPr>
+      </p:sp>
+      <p:sp>
+        <p:nvSpPr>
+          <p:cNvPr id="65" name="Text"/>
+          <p:cNvSpPr txBox="1"/>
+          <p:nvPr/>
+        </p:nvSpPr>
+        <p:spPr>
+          <a:xfrm>
+            <a:off x="3454400" y="5473700"/>
+            <a:ext cx="2095500" cy="139700"/>
+          </a:xfrm>
+          <a:prstGeom prst="rect">
+            <a:avLst/>
+          </a:prstGeom>
+          <a:noFill/>
+          <a:ln>
+            <a:noFill/>
+          </a:ln>
+        </p:spPr>
+        <p:txBody>
+          <a:bodyPr wrap="square" lIns="0" tIns="0" rIns="0" bIns="0"/>
+          <a:lstStyle/>
+          <a:p>
+            <a:r>
+              <a:rPr lang="hr-HR" sz="1250" b="1">
+                <a:solidFill>
+                  <a:srgbClr val="F8F3E8"/>
+                </a:solidFill>
+                <a:latin typeface="Aptos"/>
+              </a:rPr>
+              <a:t>Unseen speakers</a:t>
+            </a:r>
+            <a:endParaRPr lang="hr-HR" sz="1250"/>
+          </a:p>
+        </p:txBody>
+      </p:sp>
+      <p:sp>
+        <p:nvSpPr>
+          <p:cNvPr id="66" name="Text"/>
+          <p:cNvSpPr txBox="1"/>
+          <p:nvPr/>
+        </p:nvSpPr>
+        <p:spPr>
+          <a:xfrm>
+            <a:off x="3454400" y="5651500"/>
+            <a:ext cx="2095500" cy="177800"/>
+          </a:xfrm>
+          <a:prstGeom prst="rect">
+            <a:avLst/>
+          </a:prstGeom>
+          <a:noFill/>
+          <a:ln>
+            <a:noFill/>
+          </a:ln>
+        </p:spPr>
+        <p:txBody>
+          <a:bodyPr wrap="square" lIns="0" tIns="0" rIns="0" bIns="0"/>
+          <a:lstStyle/>
+          <a:p>
+            <a:r>
+              <a:rPr lang="hr-HR" sz="1650" b="1">
+                <a:solidFill>
+                  <a:srgbClr val="F8F3E8"/>
+                </a:solidFill>
+                <a:latin typeface="Aptos"/>
+              </a:rPr>
+              <a:t>stroži dio testa</a:t>
+            </a:r>
+            <a:endParaRPr lang="hr-HR" sz="1650"/>
+          </a:p>
+        </p:txBody>
+      </p:sp>
+      <p:sp>
+        <p:nvSpPr>
+          <p:cNvPr id="67" name="Text"/>
+          <p:cNvSpPr txBox="1"/>
+          <p:nvPr/>
+        </p:nvSpPr>
+        <p:spPr>
+          <a:xfrm>
+            <a:off x="3454400" y="5854700"/>
+            <a:ext cx="2095500" cy="127000"/>
+          </a:xfrm>
+          <a:prstGeom prst="rect">
+            <a:avLst/>
+          </a:prstGeom>
+          <a:noFill/>
+          <a:ln>
+            <a:noFill/>
+          </a:ln>
+        </p:spPr>
+        <p:txBody>
+          <a:bodyPr wrap="square" lIns="0" tIns="0" rIns="0" bIns="0"/>
+          <a:lstStyle/>
+          <a:p>
+            <a:r>
+              <a:rPr lang="hr-HR" sz="1050">
+                <a:solidFill>
+                  <a:srgbClr val="F8F3E8"/>
+                </a:solidFill>
+                <a:latin typeface="Aptos"/>
+              </a:rPr>
+              <a:t>4.97% WER · 0.99% CER</a:t>
+            </a:r>
+            <a:endParaRPr lang="hr-HR" sz="1050"/>
+          </a:p>
+        </p:txBody>
+      </p:sp>
+      <p:sp>
+        <p:nvSpPr>
+          <p:cNvPr id="68" name="Rectangle"/>
+          <p:cNvSpPr/>
+          <p:nvPr/>
+        </p:nvSpPr>
+        <p:spPr>
+          <a:xfrm>
+            <a:off x="6032500" y="5365750"/>
+            <a:ext cx="2476500" cy="666750"/>
+          </a:xfrm>
+          <a:prstGeom prst="rect">
+            <a:avLst/>
+          </a:prstGeom>
+          <a:solidFill>
+            <a:srgbClr val="F0B429"/>
+          </a:solidFill>
+          <a:ln>
+            <a:noFill/>
+          </a:ln>
+        </p:spPr>
+      </p:sp>
+      <p:sp>
+        <p:nvSpPr>
+          <p:cNvPr id="69" name="Text"/>
+          <p:cNvSpPr txBox="1"/>
+          <p:nvPr/>
+        </p:nvSpPr>
+        <p:spPr>
+          <a:xfrm>
+            <a:off x="6184900" y="5473700"/>
+            <a:ext cx="2095500" cy="139700"/>
+          </a:xfrm>
+          <a:prstGeom prst="rect">
+            <a:avLst/>
+          </a:prstGeom>
+          <a:noFill/>
+          <a:ln>
+            <a:noFill/>
+          </a:ln>
+        </p:spPr>
+        <p:txBody>
+          <a:bodyPr wrap="square" lIns="0" tIns="0" rIns="0" bIns="0"/>
+          <a:lstStyle/>
+          <a:p>
+            <a:r>
+              <a:rPr lang="hr-HR" sz="1250" b="1">
+                <a:solidFill>
+                  <a:srgbClr val="15171A"/>
+                </a:solidFill>
+                <a:latin typeface="Aptos"/>
+              </a:rPr>
+              <a:t>LM nakon fine-tunea</a:t>
+            </a:r>
+            <a:endParaRPr lang="hr-HR" sz="1250"/>
+          </a:p>
+        </p:txBody>
+      </p:sp>
+      <p:sp>
+        <p:nvSpPr>
+          <p:cNvPr id="70" name="Text"/>
+          <p:cNvSpPr txBox="1"/>
+          <p:nvPr/>
+        </p:nvSpPr>
+        <p:spPr>
+          <a:xfrm>
+            <a:off x="6184900" y="5651500"/>
+            <a:ext cx="2095500" cy="177800"/>
+          </a:xfrm>
+          <a:prstGeom prst="rect">
+            <a:avLst/>
+          </a:prstGeom>
+          <a:noFill/>
+          <a:ln>
+            <a:noFill/>
+          </a:ln>
+        </p:spPr>
+        <p:txBody>
+          <a:bodyPr wrap="square" lIns="0" tIns="0" rIns="0" bIns="0"/>
+          <a:lstStyle/>
+          <a:p>
+            <a:r>
+              <a:rPr lang="hr-HR" sz="1650" b="1">
+                <a:solidFill>
+                  <a:srgbClr val="15171A"/>
+                </a:solidFill>
+                <a:latin typeface="Aptos"/>
+              </a:rPr>
+              <a:t>blago lošiji</a:t>
+            </a:r>
+            <a:endParaRPr lang="hr-HR" sz="1650"/>
+          </a:p>
+        </p:txBody>
+      </p:sp>
+      <p:sp>
+        <p:nvSpPr>
+          <p:cNvPr id="71" name="Text"/>
+          <p:cNvSpPr txBox="1"/>
+          <p:nvPr/>
+        </p:nvSpPr>
+        <p:spPr>
+          <a:xfrm>
+            <a:off x="6184900" y="5854700"/>
+            <a:ext cx="2095500" cy="127000"/>
+          </a:xfrm>
+          <a:prstGeom prst="rect">
+            <a:avLst/>
+          </a:prstGeom>
+          <a:noFill/>
+          <a:ln>
+            <a:noFill/>
+          </a:ln>
+        </p:spPr>
+        <p:txBody>
+          <a:bodyPr wrap="square" lIns="0" tIns="0" rIns="0" bIns="0"/>
+          <a:lstStyle/>
+          <a:p>
+            <a:r>
+              <a:rPr lang="hr-HR" sz="1050">
+                <a:solidFill>
+                  <a:srgbClr val="15171A"/>
+                </a:solidFill>
+                <a:latin typeface="Aptos"/>
+              </a:rPr>
+              <a:t>4.24% vs 3.86% WER</a:t>
+            </a:r>
+            <a:endParaRPr lang="hr-HR" sz="1050"/>
+          </a:p>
+        </p:txBody>
+      </p:sp>
+    </p:spTree>
+  </p:cSld>
+  <p:clrMapOvr>
+    <a:masterClrMapping/>
+  </p:clrMapOvr>
+</p:sld>
+</file>
+
+<file path=ppt/slides/slide9.xml><?xml version="1.0" encoding="utf-8"?>
 <p:sld xmlns:a="http://schemas.openxmlformats.org/drawingml/2006/main" xmlns:r="http://schemas.openxmlformats.org/officeDocument/2006/relationships" xmlns:p="http://schemas.openxmlformats.org/presentationml/2006/main">
   <p:cSld>
     <p:bg>

</xml_diff>

<commit_message>
Refine HF fine-tune slide wording
</commit_message>
<xml_diff>
--- a/presentation/ROGJ_Deepspeech2_topic_presentation.pptx
+++ b/presentation/ROGJ_Deepspeech2_topic_presentation.pptx
@@ -9679,7 +9679,7 @@
                 </a:solidFill>
                 <a:latin typeface="Aptos"/>
               </a:rPr>
-              <a:t>08 · ČISTA HF REPRODUKCIJA</a:t>
+              <a:t>08 · NAJBOLJI MODEL?</a:t>
             </a:r>
             <a:endParaRPr lang="hr-HR" sz="1500"/>
           </a:p>
@@ -9715,7 +9715,7 @@
                 </a:solidFill>
                 <a:latin typeface="Aptos"/>
               </a:rPr>
-              <a:t>Clean VEPRAD fine-tune reproducira 3.86% test WER.</a:t>
+              <a:t>Fine-tune postojećeg pred-treniranog modela.</a:t>
             </a:r>
             <a:endParaRPr lang="hr-HR" sz="2350"/>
           </a:p>
@@ -9751,7 +9751,7 @@
                 </a:solidFill>
                 <a:latin typeface="Aptos"/>
               </a:rPr>
-              <a:t>Zasebni HF/Wav2Vec2 run na istom clean split protokolu; nije PaddleSpeech/DeepSpeech2 trening.</a:t>
+              <a:t>CLASSLA Wav2Vec2 fine-tune na train-setu; nije PaddleSpeech/DeepSpeech2 trening.</a:t>
             </a:r>
             <a:endParaRPr lang="hr-HR" sz="1080"/>
           </a:p>
@@ -9961,7 +9961,7 @@
                 </a:solidFill>
                 <a:latin typeface="Aptos"/>
               </a:rPr>
-              <a:t>Trening</a:t>
+              <a:t>Fine-tune</a:t>
             </a:r>
             <a:endParaRPr lang="hr-HR" sz="1300"/>
           </a:p>

</xml_diff>